<commit_message>
Deck: apply red-team fixes
Removes Organika FOB and the distributor transfer price from the
economics slide, replacing it with target shelf prices against named
competitors. Corrects the official-store stat to the supplement figure
(26% of online supplement sales, Jan-May 2025) instead of the
all-category 32.6%. Reorders the range so collagen (whose economics fit
the premium band) and magnesium in a Vietnam pack lead, with greens
next. Re-dates the timeline from November 2026 (Tet 2028 on 26 Jan).
Drops overclaims about dossiers already held, softens wording that
could read as criticism of an existing partner, adds the 22% online
decline honestly, and strips hyphens. Validates and passes visual QA.

Co-Authored-By: Claude Opus 5.5 <noreply@anthropic.com>
Claude-Session: https://claude.ai/code/session_01CHL2VrJ5edbBW6zFNsXfxt
</commit_message>
<xml_diff>
--- a/vietnam-distributor-pitch.pptx
+++ b/vietnam-distributor-pitch.pptx
@@ -142,7 +142,7 @@
                 </a:solidFill>
                 <a:latin typeface="+mn-lt"/>
               </a:rPr>
-              <a:t>2025: Mall = 2% of shops, 33% of GMV</a:t>
+              <a:t>Online supplement sales, Jan to May 2025</a:t>
             </a:r>
           </a:p>
         </c:rich>
@@ -166,7 +166,7 @@
               <c:strCache>
                 <c:ptCount val="1"/>
                 <c:pt idx="0">
-                  <c:v>Share of online supplement GMV</c:v>
+                  <c:v>Share of online supplement sales</c:v>
                 </c:pt>
               </c:strCache>
             </c:strRef>
@@ -231,7 +231,7 @@
                 <c:ptCount val="2"/>
                 <c:lvl>
                   <c:pt idx="0">
-                    <c:v>Official Mall stores</c:v>
+                    <c:v>Official stores</c:v>
                   </c:pt>
                   <c:pt idx="1">
                     <c:v>Unverified sellers</c:v>
@@ -247,10 +247,10 @@
                 <c:formatCode>General</c:formatCode>
                 <c:ptCount val="2"/>
                 <c:pt idx="0">
-                  <c:v>0.326</c:v>
+                  <c:v>0.262</c:v>
                 </c:pt>
                 <c:pt idx="1">
-                  <c:v>0.674</c:v>
+                  <c:v>0.738</c:v>
                 </c:pt>
               </c:numCache>
             </c:numRef>
@@ -331,287 +331,7 @@
         <c:axId val="2094734552"/>
         <c:scaling>
           <c:orientation val="minMax"/>
-          <c:max val="0.8"/>
-        </c:scaling>
-        <c:delete val="1"/>
-        <c:axPos val="l"/>
-        <c:numFmt formatCode="General" sourceLinked="0"/>
-        <c:majorTickMark val="out"/>
-        <c:minorTickMark val="none"/>
-        <c:tickLblPos val="nextTo"/>
-        <c:spPr>
-          <a:ln w="12700" cap="flat">
-            <a:solidFill>
-              <a:srgbClr val="888888"/>
-            </a:solidFill>
-            <a:prstDash val="solid"/>
-            <a:round/>
-          </a:ln>
-        </c:spPr>
-        <c:txPr>
-          <a:bodyPr/>
-          <a:lstStyle/>
-          <a:p>
-            <a:pPr>
-              <a:defRPr sz="1200" b="0" i="0" u="none" strike="noStrike">
-                <a:solidFill>
-                  <a:srgbClr val="000000"/>
-                </a:solidFill>
-                <a:latin typeface="Arial"/>
-              </a:defRPr>
-            </a:pPr>
-            <a:endParaRPr lang="en-US"/>
-          </a:p>
-        </c:txPr>
-        <c:crossAx val="2094734554"/>
-        <c:crosses val="autoZero"/>
-        <c:crossBetween val="between"/>
-      </c:valAx>
-      <c:spPr>
-        <a:noFill/>
-        <a:ln>
-          <a:noFill/>
-        </a:ln>
-        <a:effectLst/>
-      </c:spPr>
-    </c:plotArea>
-    <c:plotVisOnly val="1"/>
-    <c:dispBlanksAs val="span"/>
-  </c:chart>
-  <c:spPr>
-    <a:noFill/>
-    <a:ln>
-      <a:noFill/>
-    </a:ln>
-    <a:effectLst/>
-  </c:spPr>
-  <c:externalData r:id="rId1">
-    <c:autoUpdate val="0"/>
-  </c:externalData>
-</c:chartSpace>
-</file>
-
-<file path=ppt/charts/chart2.xml><?xml version="1.0" encoding="utf-8"?>
-<c:chartSpace xmlns:c="http://schemas.openxmlformats.org/drawingml/2006/chart" xmlns:a="http://schemas.openxmlformats.org/drawingml/2006/main" xmlns:r="http://schemas.openxmlformats.org/officeDocument/2006/relationships">
-  <c:date1904 val="0"/>
-  <c:roundedCorners val="1"/>
-  <c:chart>
-    <c:autoTitleDeleted val="1"/>
-    <c:plotArea>
-      <c:layout/>
-      <c:barChart>
-        <c:barDir val="col"/>
-        <c:grouping val="clustered"/>
-        <c:varyColors val="0"/>
-        <c:ser>
-          <c:idx val="0"/>
-          <c:order val="0"/>
-          <c:tx>
-            <c:strRef>
-              <c:f>Sheet1!$B$1</c:f>
-              <c:strCache>
-                <c:ptCount val="1"/>
-                <c:pt idx="0">
-                  <c:v>VND per unit</c:v>
-                </c:pt>
-              </c:strCache>
-            </c:strRef>
-          </c:tx>
-          <c:spPr>
-            <a:solidFill>
-              <a:srgbClr val="97BC62"/>
-            </a:solidFill>
-            <a:effectLst/>
-          </c:spPr>
-          <c:invertIfNegative val="0"/>
-          <c:dLbls>
-            <c:numFmt formatCode="#,##0" sourceLinked="0"/>
-            <c:txPr>
-              <a:bodyPr/>
-              <a:lstStyle/>
-              <a:p>
-                <a:pPr>
-                  <a:defRPr b="0" i="0" strike="noStrike" sz="1100" u="none">
-                    <a:solidFill>
-                      <a:srgbClr val="1A1C1A"/>
-                    </a:solidFill>
-                    <a:latin typeface="+mn-lt"/>
-                  </a:defRPr>
-                </a:pPr>
-              </a:p>
-            </c:txPr>
-            <c:showLegendKey val="0"/>
-            <c:showVal val="1"/>
-            <c:showCatName val="0"/>
-            <c:showSerName val="0"/>
-            <c:showPercent val="0"/>
-            <c:showBubbleSize val="0"/>
-            <c:showLeaderLines val="0"/>
-          </c:dLbls>
-          <c:dPt>
-            <c:idx val="0"/>
-            <c:invertIfNegative val="0"/>
-            <c:bubble3D val="0"/>
-            <c:spPr>
-              <a:solidFill>
-                <a:srgbClr val="97BC62"/>
-              </a:solidFill>
-              <a:effectLst/>
-            </c:spPr>
-          </c:dPt>
-          <c:dPt>
-            <c:idx val="1"/>
-            <c:invertIfNegative val="0"/>
-            <c:bubble3D val="0"/>
-            <c:spPr>
-              <a:solidFill>
-                <a:srgbClr val="2E6B50"/>
-              </a:solidFill>
-              <a:effectLst/>
-            </c:spPr>
-          </c:dPt>
-          <c:dPt>
-            <c:idx val="2"/>
-            <c:invertIfNegative val="0"/>
-            <c:bubble3D val="0"/>
-            <c:spPr>
-              <a:solidFill>
-                <a:srgbClr val="B8860B"/>
-              </a:solidFill>
-              <a:effectLst/>
-            </c:spPr>
-          </c:dPt>
-          <c:dPt>
-            <c:idx val="3"/>
-            <c:invertIfNegative val="0"/>
-            <c:bubble3D val="0"/>
-            <c:spPr>
-              <a:solidFill>
-                <a:srgbClr val="1F4D3A"/>
-              </a:solidFill>
-              <a:effectLst/>
-            </c:spPr>
-          </c:dPt>
-          <c:cat>
-            <c:multiLvlStrRef>
-              <c:f>Sheet1!$A$2:$A$5</c:f>
-              <c:multiLvlStrCache>
-                <c:ptCount val="4"/>
-                <c:lvl>
-                  <c:pt idx="0">
-                    <c:v>FOB</c:v>
-                  </c:pt>
-                  <c:pt idx="1">
-                    <c:v>Landed</c:v>
-                  </c:pt>
-                  <c:pt idx="2">
-                    <c:v>To distributor</c:v>
-                  </c:pt>
-                  <c:pt idx="3">
-                    <c:v>Shelf price</c:v>
-                  </c:pt>
-                </c:lvl>
-              </c:multiLvlStrCache>
-            </c:multiLvlStrRef>
-          </c:cat>
-          <c:val>
-            <c:numRef>
-              <c:f>Sheet1!$B$2:$B$5</c:f>
-              <c:numCache>
-                <c:formatCode>General</c:formatCode>
-                <c:ptCount val="4"/>
-                <c:pt idx="0">
-                  <c:v>221400</c:v>
-                </c:pt>
-                <c:pt idx="1">
-                  <c:v>236700</c:v>
-                </c:pt>
-                <c:pt idx="2">
-                  <c:v>343215</c:v>
-                </c:pt>
-                <c:pt idx="3">
-                  <c:v>529532</c:v>
-                </c:pt>
-              </c:numCache>
-            </c:numRef>
-          </c:val>
-        </c:ser>
-        <c:dLbls>
-          <c:numFmt formatCode="#,##0" sourceLinked="0"/>
-          <c:txPr>
-            <a:bodyPr/>
-            <a:lstStyle/>
-            <a:p>
-              <a:pPr>
-                <a:defRPr b="0" i="0" strike="noStrike" sz="1100" u="none">
-                  <a:solidFill>
-                    <a:srgbClr val="1A1C1A"/>
-                  </a:solidFill>
-                  <a:latin typeface="+mn-lt"/>
-                </a:defRPr>
-              </a:pPr>
-            </a:p>
-          </c:txPr>
-          <c:showLegendKey val="0"/>
-          <c:showVal val="1"/>
-          <c:showCatName val="0"/>
-          <c:showSerName val="0"/>
-          <c:showPercent val="0"/>
-          <c:showBubbleSize val="0"/>
-          <c:showLeaderLines val="0"/>
-        </c:dLbls>
-        <c:gapWidth val="150"/>
-        <c:overlap val="0"/>
-        <c:axId val="2094734554"/>
-        <c:axId val="2094734552"/>
-        <c:axId val="2094734556"/>
-      </c:barChart>
-      <c:catAx>
-        <c:axId val="2094734554"/>
-        <c:scaling>
-          <c:orientation val="minMax"/>
-        </c:scaling>
-        <c:delete val="0"/>
-        <c:axPos val="b"/>
-        <c:numFmt formatCode="General" sourceLinked="1"/>
-        <c:majorTickMark val="out"/>
-        <c:minorTickMark val="none"/>
-        <c:tickLblPos val="low"/>
-        <c:spPr>
-          <a:ln w="12700" cap="flat">
-            <a:solidFill>
-              <a:srgbClr val="888888"/>
-            </a:solidFill>
-            <a:prstDash val="solid"/>
-            <a:round/>
-          </a:ln>
-        </c:spPr>
-        <c:txPr>
-          <a:bodyPr/>
-          <a:lstStyle/>
-          <a:p>
-            <a:pPr>
-              <a:defRPr sz="1100" b="0" i="0" u="none" strike="noStrike">
-                <a:solidFill>
-                  <a:srgbClr val="1A1C1A"/>
-                </a:solidFill>
-                <a:latin typeface="+mn-lt"/>
-              </a:defRPr>
-            </a:pPr>
-            <a:endParaRPr lang="en-US"/>
-          </a:p>
-        </c:txPr>
-        <c:crossAx val="2094734552"/>
-        <c:crosses val="autoZero"/>
-        <c:auto val="1"/>
-        <c:lblAlgn val="ctr"/>
-        <c:noMultiLvlLbl val="1"/>
-      </c:catAx>
-      <c:valAx>
-        <c:axId val="2094734552"/>
-        <c:scaling>
-          <c:orientation val="minMax"/>
-          <c:max val="620000"/>
+          <c:max val="0.9"/>
         </c:scaling>
         <c:delete val="1"/>
         <c:axPos val="l"/>
@@ -1066,7 +786,7 @@
           <a:p>
             <a:r>
               <a:rPr lang="en-US" dirty="0"/>
-              <a:t/>
+              <a:t>Opening: thank them for the time; Organika has sold in Vietnam for years and is planning the next phase properly.</a:t>
             </a:r>
             <a:endParaRPr lang="en-US" dirty="0"/>
           </a:p>
@@ -2233,27 +1953,7 @@
       </p:grpSpPr>
       <p:sp>
         <p:nvSpPr>
-          <p:cNvPr id="2" name="Shape 0"/>
-          <p:cNvSpPr/>
-          <p:nvPr/>
-        </p:nvSpPr>
-        <p:spPr>
-          <a:xfrm>
-            <a:off x="0" y="0"/>
-            <a:ext cx="12191695" cy="6858000"/>
-          </a:xfrm>
-          <a:prstGeom prst="rect">
-            <a:avLst/>
-          </a:prstGeom>
-          <a:solidFill>
-            <a:srgbClr val="1F4D3A"/>
-          </a:solidFill>
-          <a:ln/>
-        </p:spPr>
-      </p:sp>
-      <p:sp>
-        <p:nvSpPr>
-          <p:cNvPr id="3" name="Text 1"/>
+          <p:cNvPr id="2" name="Text 0"/>
           <p:cNvSpPr txBox="1"/>
           <p:nvPr/>
         </p:nvSpPr>
@@ -2292,7 +1992,7 @@
       </p:sp>
       <p:sp>
         <p:nvSpPr>
-          <p:cNvPr id="4" name="Text 2"/>
+          <p:cNvPr id="3" name="Text 1"/>
           <p:cNvSpPr txBox="1"/>
           <p:nvPr/>
         </p:nvSpPr>
@@ -2312,9 +2012,6 @@
           <a:lstStyle/>
           <a:p>
             <a:pPr indent="0" marL="0">
-              <a:lnSpc>
-                <a:spcPct val="100000"/>
-              </a:lnSpc>
               <a:buNone/>
             </a:pPr>
             <a:r>
@@ -2334,7 +2031,7 @@
       </p:sp>
       <p:sp>
         <p:nvSpPr>
-          <p:cNvPr id="5" name="Text 3"/>
+          <p:cNvPr id="4" name="Text 2"/>
           <p:cNvSpPr txBox="1"/>
           <p:nvPr/>
         </p:nvSpPr>
@@ -2365,7 +2062,7 @@
                 <a:ea typeface="Calibri" pitchFamily="34" charset="-122"/>
                 <a:cs typeface="Calibri" pitchFamily="34" charset="-120"/>
               </a:rPr>
-              <a:t>Collagen · Magnesium · Greens · Probiotics · Fibre · Vitamins</a:t>
+              <a:t>Collagen · Magnesium · Greens · Probiotics · Fibre</a:t>
             </a:r>
             <a:endParaRPr lang="en-US" sz="1500" dirty="0"/>
           </a:p>
@@ -2373,7 +2070,7 @@
       </p:sp>
       <p:sp>
         <p:nvSpPr>
-          <p:cNvPr id="6" name="Text 4"/>
+          <p:cNvPr id="5" name="Text 3"/>
           <p:cNvSpPr txBox="1"/>
           <p:nvPr/>
         </p:nvSpPr>
@@ -2404,7 +2101,7 @@
                 <a:ea typeface="Calibri" pitchFamily="34" charset="-122"/>
                 <a:cs typeface="Calibri" pitchFamily="34" charset="-120"/>
               </a:rPr>
-              <a:t>Louis To · Senior Sales Manager, Emerging Channels</a:t>
+              <a:t>Louis To · Senior Sales Manager, Emerging Channels · Organika Health Products</a:t>
             </a:r>
             <a:endParaRPr lang="en-US" sz="1200" dirty="0"/>
           </a:p>
@@ -2503,13 +2200,10 @@
           <a:lstStyle/>
           <a:p>
             <a:pPr indent="0" marL="0">
-              <a:lnSpc>
-                <a:spcPct val="105000"/>
-              </a:lnSpc>
-              <a:buNone/>
-            </a:pPr>
-            <a:r>
-              <a:rPr lang="en-US" sz="3200" b="1" dirty="0">
+              <a:buNone/>
+            </a:pPr>
+            <a:r>
+              <a:rPr lang="en-US" sz="3000" b="1" dirty="0">
                 <a:solidFill>
                   <a:srgbClr val="FFFFFF"/>
                 </a:solidFill>
@@ -2517,9 +2211,9 @@
                 <a:ea typeface="Cambria" pitchFamily="34" charset="-122"/>
                 <a:cs typeface="Cambria" pitchFamily="34" charset="-120"/>
               </a:rPr>
-              <a:t>A short call to share the range, the price ladder, and the dossier we already hold</a:t>
-            </a:r>
-            <a:endParaRPr lang="en-US" sz="3200" dirty="0"/>
+              <a:t>Agree the range, the pack plan and the registration plan, then set the first milestones together</a:t>
+            </a:r>
+            <a:endParaRPr lang="en-US" sz="3000" dirty="0"/>
           </a:p>
         </p:txBody>
       </p:sp>
@@ -2666,7 +2360,7 @@
                 <a:ea typeface="Cambria" pitchFamily="34" charset="-122"/>
                 <a:cs typeface="Cambria" pitchFamily="34" charset="-120"/>
               </a:rPr>
-              <a:t>A market worth entering, carefully</a:t>
+              <a:t>A market worth building, carefully</a:t>
             </a:r>
             <a:endParaRPr lang="en-US" sz="3000" dirty="0"/>
           </a:p>
@@ -2709,7 +2403,7 @@
         </p:nvSpPr>
         <p:spPr>
           <a:xfrm>
-            <a:off x="685800" y="1965960"/>
+            <a:off x="713232" y="1965960"/>
             <a:ext cx="2331720" cy="822960"/>
           </a:xfrm>
           <a:prstGeom prst="rect">
@@ -2722,7 +2416,7 @@
           <a:bodyPr wrap="square" lIns="0" tIns="0" rIns="0" bIns="0" rtlCol="0" anchor="ctr"/>
           <a:lstStyle/>
           <a:p>
-            <a:pPr algn="l" indent="0" marL="0">
+            <a:pPr indent="0" marL="0">
               <a:buNone/>
             </a:pPr>
             <a:r>
@@ -2748,7 +2442,7 @@
         </p:nvSpPr>
         <p:spPr>
           <a:xfrm>
-            <a:off x="685800" y="2788920"/>
+            <a:off x="713232" y="2788920"/>
             <a:ext cx="2331720" cy="914400"/>
           </a:xfrm>
           <a:prstGeom prst="rect">
@@ -2773,7 +2467,7 @@
                 <a:ea typeface="Calibri" pitchFamily="34" charset="-122"/>
                 <a:cs typeface="Calibri" pitchFamily="34" charset="-120"/>
               </a:rPr>
-              <a:t>market size, 2024 (analyst consensus)</a:t>
+              <a:t>supplement market, 2024 (analyst consensus)</a:t>
             </a:r>
             <a:endParaRPr lang="en-US" sz="1200" dirty="0"/>
           </a:p>
@@ -2816,7 +2510,7 @@
         </p:nvSpPr>
         <p:spPr>
           <a:xfrm>
-            <a:off x="3502152" y="1965960"/>
+            <a:off x="3529584" y="1965960"/>
             <a:ext cx="2331720" cy="822960"/>
           </a:xfrm>
           <a:prstGeom prst="rect">
@@ -2829,7 +2523,7 @@
           <a:bodyPr wrap="square" lIns="0" tIns="0" rIns="0" bIns="0" rtlCol="0" anchor="ctr"/>
           <a:lstStyle/>
           <a:p>
-            <a:pPr algn="l" indent="0" marL="0">
+            <a:pPr indent="0" marL="0">
               <a:buNone/>
             </a:pPr>
             <a:r>
@@ -2855,7 +2549,7 @@
         </p:nvSpPr>
         <p:spPr>
           <a:xfrm>
-            <a:off x="3502152" y="2788920"/>
+            <a:off x="3529584" y="2788920"/>
             <a:ext cx="2331720" cy="914400"/>
           </a:xfrm>
           <a:prstGeom prst="rect">
@@ -2880,7 +2574,7 @@
                 <a:ea typeface="Calibri" pitchFamily="34" charset="-122"/>
                 <a:cs typeface="Calibri" pitchFamily="34" charset="-120"/>
               </a:rPr>
-              <a:t>growth to ~US$1.7B by 2030</a:t>
+              <a:t>growth, to ~US$1.7B by 2030</a:t>
             </a:r>
             <a:endParaRPr lang="en-US" sz="1200" dirty="0"/>
           </a:p>
@@ -2923,7 +2617,7 @@
         </p:nvSpPr>
         <p:spPr>
           <a:xfrm>
-            <a:off x="6318504" y="1965960"/>
+            <a:off x="6345936" y="1965960"/>
             <a:ext cx="2331720" cy="822960"/>
           </a:xfrm>
           <a:prstGeom prst="rect">
@@ -2936,7 +2630,7 @@
           <a:bodyPr wrap="square" lIns="0" tIns="0" rIns="0" bIns="0" rtlCol="0" anchor="ctr"/>
           <a:lstStyle/>
           <a:p>
-            <a:pPr algn="l" indent="0" marL="0">
+            <a:pPr indent="0" marL="0">
               <a:buNone/>
             </a:pPr>
             <a:r>
@@ -2962,7 +2656,7 @@
         </p:nvSpPr>
         <p:spPr>
           <a:xfrm>
-            <a:off x="6318504" y="2788920"/>
+            <a:off x="6345936" y="2788920"/>
             <a:ext cx="2331720" cy="914400"/>
           </a:xfrm>
           <a:prstGeom prst="rect">
@@ -2987,7 +2681,7 @@
                 <a:ea typeface="Calibri" pitchFamily="34" charset="-122"/>
                 <a:cs typeface="Calibri" pitchFamily="34" charset="-120"/>
               </a:rPr>
-              <a:t>fastest-growing supplement market in SE Asia</a:t>
+              <a:t>fastest growing supplement market in Southeast Asia</a:t>
             </a:r>
             <a:endParaRPr lang="en-US" sz="1200" dirty="0"/>
           </a:p>
@@ -3030,7 +2724,7 @@
         </p:nvSpPr>
         <p:spPr>
           <a:xfrm>
-            <a:off x="9134856" y="1965960"/>
+            <a:off x="9162288" y="1965960"/>
             <a:ext cx="2331720" cy="822960"/>
           </a:xfrm>
           <a:prstGeom prst="rect">
@@ -3043,7 +2737,7 @@
           <a:bodyPr wrap="square" lIns="0" tIns="0" rIns="0" bIns="0" rtlCol="0" anchor="ctr"/>
           <a:lstStyle/>
           <a:p>
-            <a:pPr algn="l" indent="0" marL="0">
+            <a:pPr indent="0" marL="0">
               <a:buNone/>
             </a:pPr>
             <a:r>
@@ -3055,7 +2749,7 @@
                 <a:ea typeface="Cambria" pitchFamily="34" charset="-122"/>
                 <a:cs typeface="Cambria" pitchFamily="34" charset="-120"/>
               </a:rPr>
-              <a:t>32.6%</a:t>
+              <a:t>1 in 4</a:t>
             </a:r>
             <a:endParaRPr lang="en-US" sz="3400" dirty="0"/>
           </a:p>
@@ -3069,7 +2763,7 @@
         </p:nvSpPr>
         <p:spPr>
           <a:xfrm>
-            <a:off x="9134856" y="2788920"/>
+            <a:off x="9162288" y="2788920"/>
             <a:ext cx="2331720" cy="914400"/>
           </a:xfrm>
           <a:prstGeom prst="rect">
@@ -3094,7 +2788,7 @@
                 <a:ea typeface="Calibri" pitchFamily="34" charset="-122"/>
                 <a:cs typeface="Calibri" pitchFamily="34" charset="-120"/>
               </a:rPr>
-              <a:t>of online category GMV now from official stores (up from a sliver)</a:t>
+              <a:t>online supplement sales now through official stores (Jan to May 2025)</a:t>
             </a:r>
             <a:endParaRPr lang="en-US" sz="1200" dirty="0"/>
           </a:p>
@@ -3133,7 +2827,7 @@
                 <a:ea typeface="Calibri" pitchFamily="34" charset="-122"/>
                 <a:cs typeface="Calibri" pitchFamily="34" charset="-120"/>
               </a:rPr>
-              <a:t>The 2025 counterfeit crackdown moved demand decisively toward provably genuine imports. That shift is the opening.</a:t>
+              <a:t>The 2025 counterfeit crackdown pushed shoppers toward provably genuine imports. That shift is the opening.</a:t>
             </a:r>
             <a:endParaRPr lang="en-US" sz="1400" dirty="0"/>
           </a:p>
@@ -3172,7 +2866,7 @@
                 <a:ea typeface="Calibri" pitchFamily="34" charset="-122"/>
                 <a:cs typeface="Calibri" pitchFamily="34" charset="-120"/>
               </a:rPr>
-              <a:t>Sources: Grand View Research, Ken Research, Euromonitor, Metric.vn, 2024–26. Figures carry confidence ratings in the full primer.</a:t>
+              <a:t>Sources: Grand View Research and Ken Research (2025); Euromonitor via NutraIngredients (2026); Metric.vn platform data via Đại Biểu Nhân Dân (2025).</a:t>
             </a:r>
             <a:endParaRPr lang="en-US" sz="900" dirty="0"/>
           </a:p>
@@ -3389,7 +3083,7 @@
                 <a:ea typeface="Calibri" pitchFamily="34" charset="-122"/>
                 <a:cs typeface="Calibri" pitchFamily="34" charset="-120"/>
               </a:rPr>
-              <a:t>CROWDED — avoid head-on</a:t>
+              <a:t>CROWDED</a:t>
             </a:r>
             <a:endParaRPr lang="en-US" sz="1400" dirty="0"/>
           </a:p>
@@ -3403,17 +3097,17 @@
         </p:nvSpPr>
         <p:spPr>
           <a:xfrm>
-            <a:off x="868680" y="2286000"/>
-            <a:ext cx="4937760" cy="640080"/>
-          </a:xfrm>
-          <a:prstGeom prst="rect">
-            <a:avLst/>
-          </a:prstGeom>
-          <a:noFill/>
-          <a:ln/>
-        </p:spPr>
-        <p:txBody>
-          <a:bodyPr wrap="square" lIns="0" tIns="0" rIns="0" bIns="0" rtlCol="0" anchor="ctr"/>
+            <a:off x="868680" y="2331720"/>
+            <a:ext cx="4937760" cy="704088"/>
+          </a:xfrm>
+          <a:prstGeom prst="rect">
+            <a:avLst/>
+          </a:prstGeom>
+          <a:noFill/>
+          <a:ln/>
+        </p:spPr>
+        <p:txBody>
+          <a:bodyPr wrap="square" lIns="0" tIns="0" rIns="0" bIns="0" rtlCol="0" anchor="t"/>
           <a:lstStyle/>
           <a:p>
             <a:pPr marL="342900" indent="-342900">
@@ -3429,7 +3123,7 @@
                 <a:ea typeface="Calibri" pitchFamily="34" charset="-122"/>
                 <a:cs typeface="Calibri" pitchFamily="34" charset="-120"/>
               </a:rPr>
-              <a:t>Premium beauty collagen (DHC, Orihiro, 82X, Lemona, Swisse)</a:t>
+              <a:t>Mid fish oil and multivitamins (Blackmores, Doppelherz)</a:t>
             </a:r>
             <a:endParaRPr lang="en-US" sz="1300" dirty="0"/>
           </a:p>
@@ -3443,17 +3137,17 @@
         </p:nvSpPr>
         <p:spPr>
           <a:xfrm>
-            <a:off x="868680" y="2999232"/>
-            <a:ext cx="4937760" cy="640080"/>
-          </a:xfrm>
-          <a:prstGeom prst="rect">
-            <a:avLst/>
-          </a:prstGeom>
-          <a:noFill/>
-          <a:ln/>
-        </p:spPr>
-        <p:txBody>
-          <a:bodyPr wrap="square" lIns="0" tIns="0" rIns="0" bIns="0" rtlCol="0" anchor="ctr"/>
+            <a:off x="868680" y="3081528"/>
+            <a:ext cx="4937760" cy="704088"/>
+          </a:xfrm>
+          <a:prstGeom prst="rect">
+            <a:avLst/>
+          </a:prstGeom>
+          <a:noFill/>
+          <a:ln/>
+        </p:spPr>
+        <p:txBody>
+          <a:bodyPr wrap="square" lIns="0" tIns="0" rIns="0" bIns="0" rtlCol="0" anchor="t"/>
           <a:lstStyle/>
           <a:p>
             <a:pPr marL="342900" indent="-342900">
@@ -3469,7 +3163,7 @@
                 <a:ea typeface="Calibri" pitchFamily="34" charset="-122"/>
                 <a:cs typeface="Calibri" pitchFamily="34" charset="-120"/>
               </a:rPr>
-              <a:t>Mid fish oil &amp; multivitamins (Blackmores, Doppelherz)</a:t>
+              <a:t>Red ginseng gifting (KGC and many others)</a:t>
             </a:r>
             <a:endParaRPr lang="en-US" sz="1300" dirty="0"/>
           </a:p>
@@ -3483,17 +3177,17 @@
         </p:nvSpPr>
         <p:spPr>
           <a:xfrm>
-            <a:off x="868680" y="3712464"/>
-            <a:ext cx="4937760" cy="640080"/>
-          </a:xfrm>
-          <a:prstGeom prst="rect">
-            <a:avLst/>
-          </a:prstGeom>
-          <a:noFill/>
-          <a:ln/>
-        </p:spPr>
-        <p:txBody>
-          <a:bodyPr wrap="square" lIns="0" tIns="0" rIns="0" bIns="0" rtlCol="0" anchor="ctr"/>
+            <a:off x="868680" y="3831336"/>
+            <a:ext cx="4937760" cy="704088"/>
+          </a:xfrm>
+          <a:prstGeom prst="rect">
+            <a:avLst/>
+          </a:prstGeom>
+          <a:noFill/>
+          <a:ln/>
+        </p:spPr>
+        <p:txBody>
+          <a:bodyPr wrap="square" lIns="0" tIns="0" rIns="0" bIns="0" rtlCol="0" anchor="t"/>
           <a:lstStyle/>
           <a:p>
             <a:pPr marL="342900" indent="-342900">
@@ -3509,7 +3203,7 @@
                 <a:ea typeface="Calibri" pitchFamily="34" charset="-122"/>
                 <a:cs typeface="Calibri" pitchFamily="34" charset="-120"/>
               </a:rPr>
-              <a:t>Red ginseng gifting (KGC + many)</a:t>
+              <a:t>Kids DHA and calcium (crowded, and trust damaged in 2025)</a:t>
             </a:r>
             <a:endParaRPr lang="en-US" sz="1300" dirty="0"/>
           </a:p>
@@ -3523,17 +3217,17 @@
         </p:nvSpPr>
         <p:spPr>
           <a:xfrm>
-            <a:off x="868680" y="4425696"/>
-            <a:ext cx="4937760" cy="640080"/>
-          </a:xfrm>
-          <a:prstGeom prst="rect">
-            <a:avLst/>
-          </a:prstGeom>
-          <a:noFill/>
-          <a:ln/>
-        </p:spPr>
-        <p:txBody>
-          <a:bodyPr wrap="square" lIns="0" tIns="0" rIns="0" bIns="0" rtlCol="0" anchor="ctr"/>
+            <a:off x="868680" y="4581144"/>
+            <a:ext cx="4937760" cy="704088"/>
+          </a:xfrm>
+          <a:prstGeom prst="rect">
+            <a:avLst/>
+          </a:prstGeom>
+          <a:noFill/>
+          <a:ln/>
+        </p:spPr>
+        <p:txBody>
+          <a:bodyPr wrap="square" lIns="0" tIns="0" rIns="0" bIns="0" rtlCol="0" anchor="t"/>
           <a:lstStyle/>
           <a:p>
             <a:pPr marL="342900" indent="-342900">
@@ -3549,7 +3243,7 @@
                 <a:ea typeface="Calibri" pitchFamily="34" charset="-122"/>
                 <a:cs typeface="Calibri" pitchFamily="34" charset="-120"/>
               </a:rPr>
-              <a:t>Kids DHA / calcium (crowded and trust-damaged)</a:t>
+              <a:t>Beauty collagen at mass prices (many Korean and local brands)</a:t>
             </a:r>
             <a:endParaRPr lang="en-US" sz="1300" dirty="0"/>
           </a:p>
@@ -3617,7 +3311,7 @@
                 <a:ea typeface="Calibri" pitchFamily="34" charset="-122"/>
                 <a:cs typeface="Calibri" pitchFamily="34" charset="-120"/>
               </a:rPr>
-              <a:t>OPEN — our lane</a:t>
+              <a:t>OPEN</a:t>
             </a:r>
             <a:endParaRPr lang="en-US" sz="1400" dirty="0"/>
           </a:p>
@@ -3631,17 +3325,17 @@
         </p:nvSpPr>
         <p:spPr>
           <a:xfrm>
-            <a:off x="6537960" y="2286000"/>
-            <a:ext cx="4846320" cy="640080"/>
-          </a:xfrm>
-          <a:prstGeom prst="rect">
-            <a:avLst/>
-          </a:prstGeom>
-          <a:noFill/>
-          <a:ln/>
-        </p:spPr>
-        <p:txBody>
-          <a:bodyPr wrap="square" lIns="0" tIns="0" rIns="0" bIns="0" rtlCol="0" anchor="ctr"/>
+            <a:off x="6537960" y="2331720"/>
+            <a:ext cx="4846320" cy="704088"/>
+          </a:xfrm>
+          <a:prstGeom prst="rect">
+            <a:avLst/>
+          </a:prstGeom>
+          <a:noFill/>
+          <a:ln/>
+        </p:spPr>
+        <p:txBody>
+          <a:bodyPr wrap="square" lIns="0" tIns="0" rIns="0" bIns="0" rtlCol="0" anchor="t"/>
           <a:lstStyle/>
           <a:p>
             <a:pPr marL="342900" indent="-342900">
@@ -3657,7 +3351,7 @@
                 <a:ea typeface="Calibri" pitchFamily="34" charset="-122"/>
                 <a:cs typeface="Calibri" pitchFamily="34" charset="-120"/>
               </a:rPr>
-              <a:t>Magnesium (chelated) — no official premium brand</a:t>
+              <a:t>Chelated sleep and stress magnesium: no official brand owns it</a:t>
             </a:r>
             <a:endParaRPr lang="en-US" sz="1300" dirty="0"/>
           </a:p>
@@ -3671,17 +3365,17 @@
         </p:nvSpPr>
         <p:spPr>
           <a:xfrm>
-            <a:off x="6537960" y="2999232"/>
-            <a:ext cx="4846320" cy="640080"/>
-          </a:xfrm>
-          <a:prstGeom prst="rect">
-            <a:avLst/>
-          </a:prstGeom>
-          <a:noFill/>
-          <a:ln/>
-        </p:spPr>
-        <p:txBody>
-          <a:bodyPr wrap="square" lIns="0" tIns="0" rIns="0" bIns="0" rtlCol="0" anchor="ctr"/>
+            <a:off x="6537960" y="3081528"/>
+            <a:ext cx="4846320" cy="704088"/>
+          </a:xfrm>
+          <a:prstGeom prst="rect">
+            <a:avLst/>
+          </a:prstGeom>
+          <a:noFill/>
+          <a:ln/>
+        </p:spPr>
+        <p:txBody>
+          <a:bodyPr wrap="square" lIns="0" tIns="0" rIns="0" bIns="0" rtlCol="0" anchor="t"/>
           <a:lstStyle/>
           <a:p>
             <a:pPr marL="342900" indent="-342900">
@@ -3697,7 +3391,7 @@
                 <a:ea typeface="Calibri" pitchFamily="34" charset="-122"/>
                 <a:cs typeface="Calibri" pitchFamily="34" charset="-120"/>
               </a:rPr>
-              <a:t>Greens / daily superfood — effectively vacant</a:t>
+              <a:t>Daily greens powder: only a Japanese aojiru niche</a:t>
             </a:r>
             <a:endParaRPr lang="en-US" sz="1300" dirty="0"/>
           </a:p>
@@ -3711,17 +3405,17 @@
         </p:nvSpPr>
         <p:spPr>
           <a:xfrm>
-            <a:off x="6537960" y="3712464"/>
-            <a:ext cx="4846320" cy="640080"/>
-          </a:xfrm>
-          <a:prstGeom prst="rect">
-            <a:avLst/>
-          </a:prstGeom>
-          <a:noFill/>
-          <a:ln/>
-        </p:spPr>
-        <p:txBody>
-          <a:bodyPr wrap="square" lIns="0" tIns="0" rIns="0" bIns="0" rtlCol="0" anchor="ctr"/>
+            <a:off x="6537960" y="3831336"/>
+            <a:ext cx="4846320" cy="704088"/>
+          </a:xfrm>
+          <a:prstGeom prst="rect">
+            <a:avLst/>
+          </a:prstGeom>
+          <a:noFill/>
+          <a:ln/>
+        </p:spPr>
+        <p:txBody>
+          <a:bodyPr wrap="square" lIns="0" tIns="0" rIns="0" bIns="0" rtlCol="0" anchor="t"/>
           <a:lstStyle/>
           <a:p>
             <a:pPr marL="342900" indent="-342900">
@@ -3737,7 +3431,7 @@
                 <a:ea typeface="Calibri" pitchFamily="34" charset="-122"/>
                 <a:cs typeface="Calibri" pitchFamily="34" charset="-120"/>
               </a:rPr>
-              <a:t>Menopause / 50+ non-dairy — thin</a:t>
+              <a:t>Premium Canadian collagen below Japanese prices</a:t>
             </a:r>
             <a:endParaRPr lang="en-US" sz="1300" dirty="0"/>
           </a:p>
@@ -3751,17 +3445,17 @@
         </p:nvSpPr>
         <p:spPr>
           <a:xfrm>
-            <a:off x="6537960" y="4425696"/>
-            <a:ext cx="4846320" cy="640080"/>
-          </a:xfrm>
-          <a:prstGeom prst="rect">
-            <a:avLst/>
-          </a:prstGeom>
-          <a:noFill/>
-          <a:ln/>
-        </p:spPr>
-        <p:txBody>
-          <a:bodyPr wrap="square" lIns="0" tIns="0" rIns="0" bIns="0" rtlCol="0" anchor="ctr"/>
+            <a:off x="6537960" y="4581144"/>
+            <a:ext cx="4846320" cy="704088"/>
+          </a:xfrm>
+          <a:prstGeom prst="rect">
+            <a:avLst/>
+          </a:prstGeom>
+          <a:noFill/>
+          <a:ln/>
+        </p:spPr>
+        <p:txBody>
+          <a:bodyPr wrap="square" lIns="0" tIns="0" rIns="0" bIns="0" rtlCol="0" anchor="t"/>
           <a:lstStyle/>
           <a:p>
             <a:pPr marL="342900" indent="-342900">
@@ -3777,7 +3471,7 @@
                 <a:ea typeface="Calibri" pitchFamily="34" charset="-122"/>
                 <a:cs typeface="Calibri" pitchFamily="34" charset="-120"/>
               </a:rPr>
-              <a:t>Clean-label Canadian — no flagship exists yet</a:t>
+              <a:t>Clean label Canadian: no Canadian brand at scale yet</a:t>
             </a:r>
             <a:endParaRPr lang="en-US" sz="1300" dirty="0"/>
           </a:p>
@@ -3926,7 +3620,7 @@
                 <a:ea typeface="Cambria" pitchFamily="34" charset="-122"/>
                 <a:cs typeface="Cambria" pitchFamily="34" charset="-120"/>
               </a:rPr>
-              <a:t>Lead with the open shelves, not the crowded one</a:t>
+              <a:t>Lead where Organika is open and priced to win</a:t>
             </a:r>
             <a:endParaRPr lang="en-US" sz="3000" dirty="0"/>
           </a:p>
@@ -3970,7 +3664,7 @@
         <p:spPr>
           <a:xfrm>
             <a:off x="777240" y="1819656"/>
-            <a:ext cx="3657600" cy="658368"/>
+            <a:ext cx="3474720" cy="658368"/>
           </a:xfrm>
           <a:prstGeom prst="rect">
             <a:avLst/>
@@ -3994,7 +3688,7 @@
                 <a:ea typeface="Calibri" pitchFamily="34" charset="-122"/>
                 <a:cs typeface="Calibri" pitchFamily="34" charset="-120"/>
               </a:rPr>
-              <a:t>Magnesium bisglycinate</a:t>
+              <a:t>Enhanced Collagen</a:t>
             </a:r>
             <a:endParaRPr lang="en-US" sz="1500" dirty="0"/>
           </a:p>
@@ -4008,8 +3702,8 @@
         </p:nvSpPr>
         <p:spPr>
           <a:xfrm>
-            <a:off x="4480560" y="1819656"/>
-            <a:ext cx="1463040" cy="658368"/>
+            <a:off x="4297680" y="1819656"/>
+            <a:ext cx="1371600" cy="658368"/>
           </a:xfrm>
           <a:prstGeom prst="rect">
             <a:avLst/>
@@ -4047,8 +3741,8 @@
         </p:nvSpPr>
         <p:spPr>
           <a:xfrm>
-            <a:off x="6035040" y="1819656"/>
-            <a:ext cx="5486400" cy="658368"/>
+            <a:off x="5760720" y="1819656"/>
+            <a:ext cx="5760720" cy="658368"/>
           </a:xfrm>
           <a:prstGeom prst="rect">
             <a:avLst/>
@@ -4072,7 +3766,7 @@
                 <a:ea typeface="Calibri" pitchFamily="34" charset="-122"/>
                 <a:cs typeface="Calibri" pitchFamily="34" charset="-120"/>
               </a:rPr>
-              <a:t>Own the official premium chelated gap</a:t>
+              <a:t>Fits the premium band today; Canadian quality story and a Tet gift format</a:t>
             </a:r>
             <a:endParaRPr lang="en-US" sz="1300" dirty="0"/>
           </a:p>
@@ -4116,7 +3810,7 @@
         <p:spPr>
           <a:xfrm>
             <a:off x="777240" y="2660904"/>
-            <a:ext cx="3657600" cy="658368"/>
+            <a:ext cx="3474720" cy="658368"/>
           </a:xfrm>
           <a:prstGeom prst="rect">
             <a:avLst/>
@@ -4140,7 +3834,7 @@
                 <a:ea typeface="Calibri" pitchFamily="34" charset="-122"/>
                 <a:cs typeface="Calibri" pitchFamily="34" charset="-120"/>
               </a:rPr>
-              <a:t>Greens / superfood</a:t>
+              <a:t>Magnesium bisglycinate</a:t>
             </a:r>
             <a:endParaRPr lang="en-US" sz="1500" dirty="0"/>
           </a:p>
@@ -4154,8 +3848,8 @@
         </p:nvSpPr>
         <p:spPr>
           <a:xfrm>
-            <a:off x="4480560" y="2660904"/>
-            <a:ext cx="1463040" cy="658368"/>
+            <a:off x="4297680" y="2660904"/>
+            <a:ext cx="1371600" cy="658368"/>
           </a:xfrm>
           <a:prstGeom prst="rect">
             <a:avLst/>
@@ -4193,8 +3887,8 @@
         </p:nvSpPr>
         <p:spPr>
           <a:xfrm>
-            <a:off x="6035040" y="2660904"/>
-            <a:ext cx="5486400" cy="658368"/>
+            <a:off x="5760720" y="2660904"/>
+            <a:ext cx="5760720" cy="658368"/>
           </a:xfrm>
           <a:prstGeom prst="rect">
             <a:avLst/>
@@ -4218,7 +3912,7 @@
                 <a:ea typeface="Calibri" pitchFamily="34" charset="-122"/>
                 <a:cs typeface="Calibri" pitchFamily="34" charset="-120"/>
               </a:rPr>
-              <a:t>First mover on daily greens</a:t>
+              <a:t>Open shelf; launched in a Vietnam pack sized to its price band</a:t>
             </a:r>
             <a:endParaRPr lang="en-US" sz="1300" dirty="0"/>
           </a:p>
@@ -4262,7 +3956,7 @@
         <p:spPr>
           <a:xfrm>
             <a:off x="777240" y="3502152"/>
-            <a:ext cx="3657600" cy="658368"/>
+            <a:ext cx="3474720" cy="658368"/>
           </a:xfrm>
           <a:prstGeom prst="rect">
             <a:avLst/>
@@ -4286,7 +3980,7 @@
                 <a:ea typeface="Calibri" pitchFamily="34" charset="-122"/>
                 <a:cs typeface="Calibri" pitchFamily="34" charset="-120"/>
               </a:rPr>
-              <a:t>Enhanced Collagen</a:t>
+              <a:t>Greens</a:t>
             </a:r>
             <a:endParaRPr lang="en-US" sz="1500" dirty="0"/>
           </a:p>
@@ -4300,8 +3994,8 @@
         </p:nvSpPr>
         <p:spPr>
           <a:xfrm>
-            <a:off x="4480560" y="3502152"/>
-            <a:ext cx="1463040" cy="658368"/>
+            <a:off x="4297680" y="3502152"/>
+            <a:ext cx="1371600" cy="658368"/>
           </a:xfrm>
           <a:prstGeom prst="rect">
             <a:avLst/>
@@ -4325,7 +4019,7 @@
                 <a:ea typeface="Calibri" pitchFamily="34" charset="-122"/>
                 <a:cs typeface="Calibri" pitchFamily="34" charset="-120"/>
               </a:rPr>
-              <a:t>FLAG</a:t>
+              <a:t>NEXT</a:t>
             </a:r>
             <a:endParaRPr lang="en-US" sz="1300" dirty="0"/>
           </a:p>
@@ -4339,8 +4033,8 @@
         </p:nvSpPr>
         <p:spPr>
           <a:xfrm>
-            <a:off x="6035040" y="3502152"/>
-            <a:ext cx="5486400" cy="658368"/>
+            <a:off x="5760720" y="3502152"/>
+            <a:ext cx="5760720" cy="658368"/>
           </a:xfrm>
           <a:prstGeom prst="rect">
             <a:avLst/>
@@ -4364,7 +4058,7 @@
                 <a:ea typeface="Calibri" pitchFamily="34" charset="-122"/>
                 <a:cs typeface="Calibri" pitchFamily="34" charset="-120"/>
               </a:rPr>
-              <a:t>Carries the Canada story; Tet gift format</a:t>
+              <a:t>Open shelf; follows in a smaller format so it lands inside the band</a:t>
             </a:r>
             <a:endParaRPr lang="en-US" sz="1300" dirty="0"/>
           </a:p>
@@ -4408,7 +4102,7 @@
         <p:spPr>
           <a:xfrm>
             <a:off x="777240" y="4343400"/>
-            <a:ext cx="3657600" cy="658368"/>
+            <a:ext cx="3474720" cy="658368"/>
           </a:xfrm>
           <a:prstGeom prst="rect">
             <a:avLst/>
@@ -4446,8 +4140,8 @@
         </p:nvSpPr>
         <p:spPr>
           <a:xfrm>
-            <a:off x="4480560" y="4343400"/>
-            <a:ext cx="1463040" cy="658368"/>
+            <a:off x="4297680" y="4343400"/>
+            <a:ext cx="1371600" cy="658368"/>
           </a:xfrm>
           <a:prstGeom prst="rect">
             <a:avLst/>
@@ -4485,8 +4179,8 @@
         </p:nvSpPr>
         <p:spPr>
           <a:xfrm>
-            <a:off x="6035040" y="4343400"/>
-            <a:ext cx="5486400" cy="658368"/>
+            <a:off x="5760720" y="4343400"/>
+            <a:ext cx="5760720" cy="658368"/>
           </a:xfrm>
           <a:prstGeom prst="rect">
             <a:avLst/>
@@ -4510,7 +4204,7 @@
                 <a:ea typeface="Calibri" pitchFamily="34" charset="-122"/>
                 <a:cs typeface="Calibri" pitchFamily="34" charset="-120"/>
               </a:rPr>
-              <a:t>Needs a strain/format differentiator</a:t>
+              <a:t>Joins once we have a clear strain or format advantage</a:t>
             </a:r>
             <a:endParaRPr lang="en-US" sz="1300" dirty="0"/>
           </a:p>
@@ -4554,7 +4248,7 @@
         <p:spPr>
           <a:xfrm>
             <a:off x="777240" y="5184648"/>
-            <a:ext cx="3657600" cy="658368"/>
+            <a:ext cx="3474720" cy="658368"/>
           </a:xfrm>
           <a:prstGeom prst="rect">
             <a:avLst/>
@@ -4578,7 +4272,7 @@
                 <a:ea typeface="Calibri" pitchFamily="34" charset="-122"/>
                 <a:cs typeface="Calibri" pitchFamily="34" charset="-120"/>
               </a:rPr>
-              <a:t>Fibre · Vitamin C</a:t>
+              <a:t>Fibre</a:t>
             </a:r>
             <a:endParaRPr lang="en-US" sz="1500" dirty="0"/>
           </a:p>
@@ -4592,8 +4286,8 @@
         </p:nvSpPr>
         <p:spPr>
           <a:xfrm>
-            <a:off x="4480560" y="5184648"/>
-            <a:ext cx="1463040" cy="658368"/>
+            <a:off x="4297680" y="5184648"/>
+            <a:ext cx="1371600" cy="658368"/>
           </a:xfrm>
           <a:prstGeom prst="rect">
             <a:avLst/>
@@ -4617,7 +4311,7 @@
                 <a:ea typeface="Calibri" pitchFamily="34" charset="-122"/>
                 <a:cs typeface="Calibri" pitchFamily="34" charset="-120"/>
               </a:rPr>
-              <a:t>FILLER</a:t>
+              <a:t>LATER</a:t>
             </a:r>
             <a:endParaRPr lang="en-US" sz="1300" dirty="0"/>
           </a:p>
@@ -4631,8 +4325,8 @@
         </p:nvSpPr>
         <p:spPr>
           <a:xfrm>
-            <a:off x="6035040" y="5184648"/>
-            <a:ext cx="5486400" cy="658368"/>
+            <a:off x="5760720" y="5184648"/>
+            <a:ext cx="5760720" cy="658368"/>
           </a:xfrm>
           <a:prstGeom prst="rect">
             <a:avLst/>
@@ -4656,7 +4350,7 @@
                 <a:ea typeface="Calibri" pitchFamily="34" charset="-122"/>
                 <a:cs typeface="Calibri" pitchFamily="34" charset="-120"/>
               </a:rPr>
-              <a:t>Round out the range; do not lead on price</a:t>
+              <a:t>Rounds out the range once the core is selling</a:t>
             </a:r>
             <a:endParaRPr lang="en-US" sz="1300" dirty="0"/>
           </a:p>
@@ -4805,7 +4499,7 @@
                 <a:ea typeface="Cambria" pitchFamily="34" charset="-122"/>
                 <a:cs typeface="Cambria" pitchFamily="34" charset="-120"/>
               </a:rPr>
-              <a:t>Why now: the flight to genuine goods</a:t>
+              <a:t>Why now: shoppers are moving to genuine</a:t>
             </a:r>
             <a:endParaRPr lang="en-US" sz="3000" dirty="0"/>
           </a:p>
@@ -4904,16 +4598,16 @@
         <p:spPr>
           <a:xfrm>
             <a:off x="6903720" y="2377440"/>
-            <a:ext cx="4480560" cy="914400"/>
-          </a:xfrm>
-          <a:prstGeom prst="rect">
-            <a:avLst/>
-          </a:prstGeom>
-          <a:noFill/>
-          <a:ln/>
-        </p:spPr>
-        <p:txBody>
-          <a:bodyPr wrap="square" lIns="0" tIns="0" rIns="0" bIns="0" rtlCol="0" anchor="ctr"/>
+            <a:ext cx="4480560" cy="1005840"/>
+          </a:xfrm>
+          <a:prstGeom prst="rect">
+            <a:avLst/>
+          </a:prstGeom>
+          <a:noFill/>
+          <a:ln/>
+        </p:spPr>
+        <p:txBody>
+          <a:bodyPr wrap="square" lIns="0" tIns="0" rIns="0" bIns="0" rtlCol="0" anchor="t"/>
           <a:lstStyle/>
           <a:p>
             <a:pPr marL="342900" indent="-342900">
@@ -4929,7 +4623,7 @@
                 <a:ea typeface="Calibri" pitchFamily="34" charset="-122"/>
                 <a:cs typeface="Calibri" pitchFamily="34" charset="-120"/>
               </a:rPr>
-              <a:t>67% of consumers rank "guaranteed genuine" as their #1 demand — above cheaper price or shipping</a:t>
+              <a:t>67% of online shoppers rank guaranteed genuine goods as the top improvement they want, ahead of discounts (41%)</a:t>
             </a:r>
             <a:endParaRPr lang="en-US" sz="1250" dirty="0"/>
           </a:p>
@@ -4943,17 +4637,17 @@
         </p:nvSpPr>
         <p:spPr>
           <a:xfrm>
-            <a:off x="6903720" y="3337560"/>
-            <a:ext cx="4480560" cy="914400"/>
-          </a:xfrm>
-          <a:prstGeom prst="rect">
-            <a:avLst/>
-          </a:prstGeom>
-          <a:noFill/>
-          <a:ln/>
-        </p:spPr>
-        <p:txBody>
-          <a:bodyPr wrap="square" lIns="0" tIns="0" rIns="0" bIns="0" rtlCol="0" anchor="ctr"/>
+            <a:off x="6903720" y="3429000"/>
+            <a:ext cx="4480560" cy="1005840"/>
+          </a:xfrm>
+          <a:prstGeom prst="rect">
+            <a:avLst/>
+          </a:prstGeom>
+          <a:noFill/>
+          <a:ln/>
+        </p:spPr>
+        <p:txBody>
+          <a:bodyPr wrap="square" lIns="0" tIns="0" rIns="0" bIns="0" rtlCol="0" anchor="t"/>
           <a:lstStyle/>
           <a:p>
             <a:pPr marL="342900" indent="-342900">
@@ -4969,7 +4663,7 @@
                 <a:ea typeface="Calibri" pitchFamily="34" charset="-122"/>
                 <a:cs typeface="Calibri" pitchFamily="34" charset="-120"/>
               </a:rPr>
-              <a:t>Celebrity and factory counterfeit cases ended in prison in 2025</a:t>
+              <a:t>Online supplement sales fell 22% in USD in 2025 as fakes were purged, while official stores gained share</a:t>
             </a:r>
             <a:endParaRPr lang="en-US" sz="1250" dirty="0"/>
           </a:p>
@@ -4983,17 +4677,17 @@
         </p:nvSpPr>
         <p:spPr>
           <a:xfrm>
-            <a:off x="6903720" y="4297680"/>
-            <a:ext cx="4480560" cy="914400"/>
-          </a:xfrm>
-          <a:prstGeom prst="rect">
-            <a:avLst/>
-          </a:prstGeom>
-          <a:noFill/>
-          <a:ln/>
-        </p:spPr>
-        <p:txBody>
-          <a:bodyPr wrap="square" lIns="0" tIns="0" rIns="0" bIns="0" rtlCol="0" anchor="ctr"/>
+            <a:off x="6903720" y="4480560"/>
+            <a:ext cx="4480560" cy="1005840"/>
+          </a:xfrm>
+          <a:prstGeom prst="rect">
+            <a:avLst/>
+          </a:prstGeom>
+          <a:noFill/>
+          <a:ln/>
+        </p:spPr>
+        <p:txBody>
+          <a:bodyPr wrap="square" lIns="0" tIns="0" rIns="0" bIns="0" rtlCol="0" anchor="t"/>
           <a:lstStyle/>
           <a:p>
             <a:pPr marL="342900" indent="-342900">
@@ -5009,7 +4703,7 @@
                 <a:ea typeface="Calibri" pitchFamily="34" charset="-122"/>
                 <a:cs typeface="Calibri" pitchFamily="34" charset="-120"/>
               </a:rPr>
-              <a:t>A provably authentic import with QR, a named importer and chain listing is exactly the trade the crackdown created</a:t>
+              <a:t>Influencers were jailed for false health product claims in November 2025; the former food safety chief got 20 years in January 2026</a:t>
             </a:r>
             <a:endParaRPr lang="en-US" sz="1250" dirty="0"/>
           </a:p>
@@ -5018,6 +4712,45 @@
       <p:sp>
         <p:nvSpPr>
           <p:cNvPr id="9" name="Text 6"/>
+          <p:cNvSpPr txBox="1"/>
+          <p:nvPr/>
+        </p:nvSpPr>
+        <p:spPr>
+          <a:xfrm>
+            <a:off x="548640" y="5943600"/>
+            <a:ext cx="11064240" cy="320040"/>
+          </a:xfrm>
+          <a:prstGeom prst="rect">
+            <a:avLst/>
+          </a:prstGeom>
+          <a:noFill/>
+          <a:ln/>
+        </p:spPr>
+        <p:txBody>
+          <a:bodyPr wrap="square" lIns="0" tIns="0" rIns="0" bIns="0" rtlCol="0" anchor="ctr"/>
+          <a:lstStyle/>
+          <a:p>
+            <a:pPr indent="0" marL="0">
+              <a:buNone/>
+            </a:pPr>
+            <a:r>
+              <a:rPr lang="en-US" sz="900" dirty="0">
+                <a:solidFill>
+                  <a:srgbClr val="5C635C"/>
+                </a:solidFill>
+                <a:latin typeface="Calibri" pitchFamily="34" charset="0"/>
+                <a:ea typeface="Calibri" pitchFamily="34" charset="-122"/>
+                <a:cs typeface="Calibri" pitchFamily="34" charset="-120"/>
+              </a:rPr>
+              <a:t>Sources: Metric.vn via Đại Biểu Nhân Dân (2025); VnExpress (2026); court reporting (VnExpress, Thanh Niên).</a:t>
+            </a:r>
+            <a:endParaRPr lang="en-US" sz="900" dirty="0"/>
+          </a:p>
+        </p:txBody>
+      </p:sp>
+      <p:sp>
+        <p:nvSpPr>
+          <p:cNvPr id="10" name="Text 7"/>
           <p:cNvSpPr txBox="1"/>
           <p:nvPr/>
         </p:nvSpPr>
@@ -5056,7 +4789,7 @@
       </p:sp>
       <p:sp>
         <p:nvSpPr>
-          <p:cNvPr id="10" name="Text 7"/>
+          <p:cNvPr id="11" name="Text 8"/>
           <p:cNvSpPr txBox="1"/>
           <p:nvPr/>
         </p:nvSpPr>
@@ -5226,7 +4959,7 @@
                 <a:ea typeface="Calibri" pitchFamily="34" charset="-122"/>
                 <a:cs typeface="Calibri" pitchFamily="34" charset="-120"/>
               </a:rPr>
-              <a:t>Registration-ready</a:t>
+              <a:t>Registration support</a:t>
             </a:r>
             <a:endParaRPr lang="en-US" sz="1500" dirty="0"/>
           </a:p>
@@ -5265,7 +4998,7 @@
                 <a:ea typeface="Calibri" pitchFamily="34" charset="-122"/>
                 <a:cs typeface="Calibri" pitchFamily="34" charset="-120"/>
               </a:rPr>
-              <a:t>Consularized free-sale certificate, GMP, lab tests, claim evidence — the dossier gate, cleared</a:t>
+              <a:t>GMP certified Canadian manufacturing, free sale certificates and lab testing to build each dossier</a:t>
             </a:r>
             <a:endParaRPr lang="en-US" sz="1200" dirty="0"/>
           </a:p>
@@ -5372,7 +5105,7 @@
                 <a:ea typeface="Calibri" pitchFamily="34" charset="-122"/>
                 <a:cs typeface="Calibri" pitchFamily="34" charset="-120"/>
               </a:rPr>
-              <a:t>A launch budget: pharmacist education, KOC within the rules, Mall-store vouchers</a:t>
+              <a:t>A launch budget for pharmacist education, compliant KOC content and official store vouchers</a:t>
             </a:r>
             <a:endParaRPr lang="en-US" sz="1200" dirty="0"/>
           </a:p>
@@ -5440,7 +5173,7 @@
                 <a:ea typeface="Calibri" pitchFamily="34" charset="-122"/>
                 <a:cs typeface="Calibri" pitchFamily="34" charset="-120"/>
               </a:rPr>
-              <a:t>Grey-market control</a:t>
+              <a:t>Grey market control</a:t>
             </a:r>
             <a:endParaRPr lang="en-US" sz="1500" dirty="0"/>
           </a:p>
@@ -5479,7 +5212,7 @@
                 <a:ea typeface="Calibri" pitchFamily="34" charset="-122"/>
                 <a:cs typeface="Calibri" pitchFamily="34" charset="-120"/>
               </a:rPr>
-              <a:t>Vietnam-specific packs and a price ladder so our own Canadian stock does not undercut you</a:t>
+              <a:t>Vietnam packs and a price ladder so stock bought abroad does not undercut your shelf</a:t>
             </a:r>
             <a:endParaRPr lang="en-US" sz="1200" dirty="0"/>
           </a:p>
@@ -5586,7 +5319,7 @@
                 <a:ea typeface="Calibri" pitchFamily="34" charset="-122"/>
                 <a:cs typeface="Calibri" pitchFamily="34" charset="-120"/>
               </a:rPr>
-              <a:t>List prices built 25–35% above everyday-promo so Tet and double-days are fundable</a:t>
+              <a:t>List prices set with room for Tet and double day campaigns</a:t>
             </a:r>
             <a:endParaRPr lang="en-US" sz="1200" dirty="0"/>
           </a:p>
@@ -5693,7 +5426,7 @@
                 <a:ea typeface="Calibri" pitchFamily="34" charset="-122"/>
                 <a:cs typeface="Calibri" pitchFamily="34" charset="-120"/>
               </a:rPr>
-              <a:t>Canada ranks #1 on the 2022 global food-safety quality sub-index</a:t>
+              <a:t>Canada ranked first in the world on food quality and safety (Global Food Security Index, 2022)</a:t>
             </a:r>
             <a:endParaRPr lang="en-US" sz="1200" dirty="0"/>
           </a:p>
@@ -5761,7 +5494,7 @@
                 <a:ea typeface="Calibri" pitchFamily="34" charset="-122"/>
                 <a:cs typeface="Calibri" pitchFamily="34" charset="-120"/>
               </a:rPr>
-              <a:t>We hold the registrations</a:t>
+              <a:t>A clear registration plan</a:t>
             </a:r>
             <a:endParaRPr lang="en-US" sz="1500" dirty="0"/>
           </a:p>
@@ -5800,7 +5533,7 @@
                 <a:ea typeface="Calibri" pitchFamily="34" charset="-122"/>
                 <a:cs typeface="Calibri" pitchFamily="34" charset="-120"/>
               </a:rPr>
-              <a:t>So neither side is ever held hostage if the relationship changes</a:t>
+              <a:t>Who files, who holds, and how a handover works, agreed up front in writing</a:t>
             </a:r>
             <a:endParaRPr lang="en-US" sz="1200" dirty="0"/>
           </a:p>
@@ -6032,7 +5765,7 @@
         <p:spPr>
           <a:xfrm>
             <a:off x="1828800" y="2029968"/>
-            <a:ext cx="3657600" cy="457200"/>
+            <a:ext cx="5486400" cy="457200"/>
           </a:xfrm>
           <a:prstGeom prst="rect">
             <a:avLst/>
@@ -6095,7 +5828,7 @@
                 <a:ea typeface="Calibri" pitchFamily="34" charset="-122"/>
                 <a:cs typeface="Calibri" pitchFamily="34" charset="-120"/>
               </a:rPr>
-              <a:t>Pharmacy chains — Long Chau first — plus official Mall stores on Shopee and TikTok Shop</a:t>
+              <a:t>Pharmacy chains, Long Chau first, plus official stores on Shopee and TikTok Shop</a:t>
             </a:r>
             <a:endParaRPr lang="en-US" sz="1300" dirty="0"/>
           </a:p>
@@ -6178,7 +5911,7 @@
         <p:spPr>
           <a:xfrm>
             <a:off x="1828800" y="3401568"/>
-            <a:ext cx="3657600" cy="457200"/>
+            <a:ext cx="5486400" cy="457200"/>
           </a:xfrm>
           <a:prstGeom prst="rect">
             <a:avLst/>
@@ -6241,7 +5974,7 @@
                 <a:ea typeface="Calibri" pitchFamily="34" charset="-122"/>
                 <a:cs typeface="Calibri" pitchFamily="34" charset="-120"/>
               </a:rPr>
-              <a:t>National exclusivity gated on volume milestones, so you carry the upside and we both invest</a:t>
+              <a:t>National exclusivity tied to agreed volume milestones, so both sides have a reason to invest</a:t>
             </a:r>
             <a:endParaRPr lang="en-US" sz="1300" dirty="0"/>
           </a:p>
@@ -6324,7 +6057,7 @@
         <p:spPr>
           <a:xfrm>
             <a:off x="1828800" y="4773168"/>
-            <a:ext cx="3657600" cy="457200"/>
+            <a:ext cx="5486400" cy="457200"/>
           </a:xfrm>
           <a:prstGeom prst="rect">
             <a:avLst/>
@@ -6348,7 +6081,7 @@
                 <a:ea typeface="Calibri" pitchFamily="34" charset="-122"/>
                 <a:cs typeface="Calibri" pitchFamily="34" charset="-120"/>
               </a:rPr>
-              <a:t>A named owner</a:t>
+              <a:t>One accountable owner</a:t>
             </a:r>
             <a:endParaRPr lang="en-US" sz="1700" dirty="0"/>
           </a:p>
@@ -6387,7 +6120,7 @@
                 <a:ea typeface="Calibri" pitchFamily="34" charset="-122"/>
                 <a:cs typeface="Calibri" pitchFamily="34" charset="-120"/>
               </a:rPr>
-              <a:t>A brand manager who treats this as a build, not a filler line on a catalogue</a:t>
+              <a:t>A named brand owner for Organika and a quarterly business review together</a:t>
             </a:r>
             <a:endParaRPr lang="en-US" sz="1300" dirty="0"/>
           </a:p>
@@ -6536,7 +6269,7 @@
                 <a:ea typeface="Cambria" pitchFamily="34" charset="-122"/>
                 <a:cs typeface="Cambria" pitchFamily="34" charset="-120"/>
               </a:rPr>
-              <a:t>The economics work, with promo room built in</a:t>
+              <a:t>Priced to win the shelf, with room to promote</a:t>
             </a:r>
             <a:endParaRPr lang="en-US" sz="3000" dirty="0"/>
           </a:p>
@@ -6575,46 +6308,30 @@
                 <a:ea typeface="Calibri" pitchFamily="34" charset="-122"/>
                 <a:cs typeface="Calibri" pitchFamily="34" charset="-120"/>
               </a:rPr>
-              <a:t>Illustrative, premium collagen, CAD 12 FOB at CPTPP 0% duty — model, to be set on real costs</a:t>
+              <a:t>Target shelf prices; final pricing is set together with our partner</a:t>
             </a:r>
             <a:endParaRPr lang="en-US" sz="1300" dirty="0"/>
           </a:p>
         </p:txBody>
       </p:sp>
-      <p:graphicFrame>
-        <p:nvGraphicFramePr>
-          <p:cNvPr id="4" name="Chart 0" descr=""/>
-          <p:cNvGraphicFramePr/>
-          <p:nvPr/>
-        </p:nvGraphicFramePr>
-        <p:xfrm>
-          <a:off x="548640" y="1783080"/>
-          <a:ext cx="6766560" cy="3931920"/>
-        </p:xfrm>
-        <a:graphic xmlns:a="http://schemas.openxmlformats.org/drawingml/2006/main">
-          <a:graphicData uri="http://schemas.openxmlformats.org/drawingml/2006/chart">
-            <c:chart xmlns:c="http://schemas.openxmlformats.org/drawingml/2006/chart" r:id="rId1"/>
-          </a:graphicData>
-        </a:graphic>
-      </p:graphicFrame>
-      <p:sp>
-        <p:nvSpPr>
-          <p:cNvPr id="5" name="Shape 2"/>
+      <p:sp>
+        <p:nvSpPr>
+          <p:cNvPr id="4" name="Shape 2"/>
           <p:cNvSpPr/>
           <p:nvPr/>
         </p:nvSpPr>
         <p:spPr>
           <a:xfrm>
-            <a:off x="7589520" y="1783080"/>
-            <a:ext cx="4023360" cy="3931920"/>
+            <a:off x="548640" y="1691640"/>
+            <a:ext cx="11064240" cy="1298448"/>
           </a:xfrm>
           <a:prstGeom prst="roundRect">
             <a:avLst>
-              <a:gd name="adj" fmla="val 1860"/>
+              <a:gd name="adj" fmla="val 5634"/>
             </a:avLst>
           </a:prstGeom>
           <a:solidFill>
-            <a:srgbClr val="EEF0EC"/>
+            <a:srgbClr val="E8F0EA"/>
           </a:solidFill>
           <a:ln/>
           <a:effectLst>
@@ -6628,30 +6345,69 @@
       </p:sp>
       <p:sp>
         <p:nvSpPr>
-          <p:cNvPr id="6" name="Text 3"/>
-          <p:cNvSpPr txBox="1"/>
-          <p:nvPr/>
-        </p:nvSpPr>
-        <p:spPr>
-          <a:xfrm>
-            <a:off x="7818120" y="2011680"/>
-            <a:ext cx="3566160" cy="822960"/>
-          </a:xfrm>
-          <a:prstGeom prst="rect">
-            <a:avLst/>
-          </a:prstGeom>
-          <a:noFill/>
-          <a:ln/>
-        </p:spPr>
-        <p:txBody>
-          <a:bodyPr wrap="square" lIns="0" tIns="0" rIns="0" bIns="0" rtlCol="0" anchor="ctr"/>
-          <a:lstStyle/>
-          <a:p>
-            <a:pPr indent="0" marL="0">
-              <a:buNone/>
-            </a:pPr>
-            <a:r>
-              <a:rPr lang="en-US" sz="4400" b="1" dirty="0">
+          <p:cNvPr id="5" name="Text 3"/>
+          <p:cNvSpPr txBox="1"/>
+          <p:nvPr/>
+        </p:nvSpPr>
+        <p:spPr>
+          <a:xfrm>
+            <a:off x="777240" y="1856232"/>
+            <a:ext cx="3566160" cy="960120"/>
+          </a:xfrm>
+          <a:prstGeom prst="rect">
+            <a:avLst/>
+          </a:prstGeom>
+          <a:noFill/>
+          <a:ln/>
+        </p:spPr>
+        <p:txBody>
+          <a:bodyPr wrap="square" lIns="0" tIns="0" rIns="0" bIns="0" rtlCol="0" anchor="ctr"/>
+          <a:lstStyle/>
+          <a:p>
+            <a:pPr indent="0" marL="0">
+              <a:buNone/>
+            </a:pPr>
+            <a:r>
+              <a:rPr lang="en-US" sz="1600" b="1" dirty="0">
+                <a:solidFill>
+                  <a:srgbClr val="1A1C1A"/>
+                </a:solidFill>
+                <a:latin typeface="Calibri" pitchFamily="34" charset="0"/>
+                <a:ea typeface="Calibri" pitchFamily="34" charset="-122"/>
+                <a:cs typeface="Calibri" pitchFamily="34" charset="-120"/>
+              </a:rPr>
+              <a:t>Enhanced Collagen 250g</a:t>
+            </a:r>
+            <a:endParaRPr lang="en-US" sz="1600" dirty="0"/>
+          </a:p>
+        </p:txBody>
+      </p:sp>
+      <p:sp>
+        <p:nvSpPr>
+          <p:cNvPr id="6" name="Text 4"/>
+          <p:cNvSpPr txBox="1"/>
+          <p:nvPr/>
+        </p:nvSpPr>
+        <p:spPr>
+          <a:xfrm>
+            <a:off x="4389120" y="1856232"/>
+            <a:ext cx="2651760" cy="960120"/>
+          </a:xfrm>
+          <a:prstGeom prst="rect">
+            <a:avLst/>
+          </a:prstGeom>
+          <a:noFill/>
+          <a:ln/>
+        </p:spPr>
+        <p:txBody>
+          <a:bodyPr wrap="square" lIns="0" tIns="0" rIns="0" bIns="0" rtlCol="0" anchor="ctr"/>
+          <a:lstStyle/>
+          <a:p>
+            <a:pPr indent="0" marL="0">
+              <a:buNone/>
+            </a:pPr>
+            <a:r>
+              <a:rPr lang="en-US" sz="2600" b="1" dirty="0">
                 <a:solidFill>
                   <a:srgbClr val="1F4D3A"/>
                 </a:solidFill>
@@ -6659,38 +6415,38 @@
                 <a:ea typeface="Cambria" pitchFamily="34" charset="-122"/>
                 <a:cs typeface="Cambria" pitchFamily="34" charset="-120"/>
               </a:rPr>
-              <a:t>2.4×</a:t>
-            </a:r>
-            <a:endParaRPr lang="en-US" sz="4400" dirty="0"/>
-          </a:p>
-        </p:txBody>
-      </p:sp>
-      <p:sp>
-        <p:nvSpPr>
-          <p:cNvPr id="7" name="Text 4"/>
-          <p:cNvSpPr txBox="1"/>
-          <p:nvPr/>
-        </p:nvSpPr>
-        <p:spPr>
-          <a:xfrm>
-            <a:off x="7818120" y="2880360"/>
-            <a:ext cx="3566160" cy="1188720"/>
-          </a:xfrm>
-          <a:prstGeom prst="rect">
-            <a:avLst/>
-          </a:prstGeom>
-          <a:noFill/>
-          <a:ln/>
-        </p:spPr>
-        <p:txBody>
-          <a:bodyPr wrap="square" lIns="0" tIns="0" rIns="0" bIns="0" rtlCol="0" anchor="ctr"/>
-          <a:lstStyle/>
-          <a:p>
-            <a:pPr indent="0" marL="0">
-              <a:buNone/>
-            </a:pPr>
-            <a:r>
-              <a:rPr lang="en-US" sz="1300" dirty="0">
+              <a:t>VND 650–700k</a:t>
+            </a:r>
+            <a:endParaRPr lang="en-US" sz="2600" dirty="0"/>
+          </a:p>
+        </p:txBody>
+      </p:sp>
+      <p:sp>
+        <p:nvSpPr>
+          <p:cNvPr id="7" name="Text 5"/>
+          <p:cNvSpPr txBox="1"/>
+          <p:nvPr/>
+        </p:nvSpPr>
+        <p:spPr>
+          <a:xfrm>
+            <a:off x="7132320" y="1819656"/>
+            <a:ext cx="4297680" cy="640080"/>
+          </a:xfrm>
+          <a:prstGeom prst="rect">
+            <a:avLst/>
+          </a:prstGeom>
+          <a:noFill/>
+          <a:ln/>
+        </p:spPr>
+        <p:txBody>
+          <a:bodyPr wrap="square" lIns="0" tIns="0" rIns="0" bIns="0" rtlCol="0" anchor="ctr"/>
+          <a:lstStyle/>
+          <a:p>
+            <a:pPr indent="0" marL="0">
+              <a:buNone/>
+            </a:pPr>
+            <a:r>
+              <a:rPr lang="en-US" sz="1200" dirty="0">
                 <a:solidFill>
                   <a:srgbClr val="5C635C"/>
                 </a:solidFill>
@@ -6698,38 +6454,38 @@
                 <a:ea typeface="Calibri" pitchFamily="34" charset="-122"/>
                 <a:cs typeface="Calibri" pitchFamily="34" charset="-120"/>
               </a:rPr>
-              <a:t>FOB-to-shelf multiple — inside the VND 650–850k premium collagen band, with headroom to price up</a:t>
-            </a:r>
-            <a:endParaRPr lang="en-US" sz="1300" dirty="0"/>
-          </a:p>
-        </p:txBody>
-      </p:sp>
-      <p:sp>
-        <p:nvSpPr>
-          <p:cNvPr id="8" name="Text 5"/>
-          <p:cNvSpPr txBox="1"/>
-          <p:nvPr/>
-        </p:nvSpPr>
-        <p:spPr>
-          <a:xfrm>
-            <a:off x="7818120" y="4937760"/>
-            <a:ext cx="3566160" cy="640080"/>
-          </a:xfrm>
-          <a:prstGeom prst="rect">
-            <a:avLst/>
-          </a:prstGeom>
-          <a:noFill/>
-          <a:ln/>
-        </p:spPr>
-        <p:txBody>
-          <a:bodyPr wrap="square" lIns="0" tIns="0" rIns="0" bIns="0" rtlCol="0" anchor="ctr"/>
-          <a:lstStyle/>
-          <a:p>
-            <a:pPr indent="0" marL="0">
-              <a:buNone/>
-            </a:pPr>
-            <a:r>
-              <a:rPr lang="en-US" sz="1100" i="1" dirty="0">
+              <a:t>Japanese and Korean premium collagen sells at VND 650–850k</a:t>
+            </a:r>
+            <a:endParaRPr lang="en-US" sz="1200" dirty="0"/>
+          </a:p>
+        </p:txBody>
+      </p:sp>
+      <p:sp>
+        <p:nvSpPr>
+          <p:cNvPr id="8" name="Text 6"/>
+          <p:cNvSpPr txBox="1"/>
+          <p:nvPr/>
+        </p:nvSpPr>
+        <p:spPr>
+          <a:xfrm>
+            <a:off x="7132320" y="2459736"/>
+            <a:ext cx="4297680" cy="384048"/>
+          </a:xfrm>
+          <a:prstGeom prst="rect">
+            <a:avLst/>
+          </a:prstGeom>
+          <a:noFill/>
+          <a:ln/>
+        </p:spPr>
+        <p:txBody>
+          <a:bodyPr wrap="square" lIns="0" tIns="0" rIns="0" bIns="0" rtlCol="0" anchor="ctr"/>
+          <a:lstStyle/>
+          <a:p>
+            <a:pPr indent="0" marL="0">
+              <a:buNone/>
+            </a:pPr>
+            <a:r>
+              <a:rPr lang="en-US" sz="1200" b="1" dirty="0">
                 <a:solidFill>
                   <a:srgbClr val="C56A45"/>
                 </a:solidFill>
@@ -6737,15 +6493,424 @@
                 <a:ea typeface="Calibri" pitchFamily="34" charset="-122"/>
                 <a:cs typeface="Calibri" pitchFamily="34" charset="-120"/>
               </a:rPr>
-              <a:t>A live calculator and a full SKU model accompany this deck.</a:t>
-            </a:r>
-            <a:endParaRPr lang="en-US" sz="1100" dirty="0"/>
-          </a:p>
-        </p:txBody>
-      </p:sp>
-      <p:sp>
-        <p:nvSpPr>
-          <p:cNvPr id="9" name="Text 6"/>
+              <a:t>Entry point of the premium band</a:t>
+            </a:r>
+            <a:endParaRPr lang="en-US" sz="1200" dirty="0"/>
+          </a:p>
+        </p:txBody>
+      </p:sp>
+      <p:sp>
+        <p:nvSpPr>
+          <p:cNvPr id="9" name="Shape 7"/>
+          <p:cNvSpPr/>
+          <p:nvPr/>
+        </p:nvSpPr>
+        <p:spPr>
+          <a:xfrm>
+            <a:off x="548640" y="3154680"/>
+            <a:ext cx="11064240" cy="1298448"/>
+          </a:xfrm>
+          <a:prstGeom prst="roundRect">
+            <a:avLst>
+              <a:gd name="adj" fmla="val 5634"/>
+            </a:avLst>
+          </a:prstGeom>
+          <a:solidFill>
+            <a:srgbClr val="EEF0EC"/>
+          </a:solidFill>
+          <a:ln/>
+          <a:effectLst>
+            <a:outerShdw sx="100000" sy="100000" kx="0" ky="0" algn="bl" rotWithShape="0" blurRad="63500" dist="25400" dir="5400000">
+              <a:srgbClr val="BBBBBB">
+                <a:alpha val="35000"/>
+              </a:srgbClr>
+            </a:outerShdw>
+          </a:effectLst>
+        </p:spPr>
+      </p:sp>
+      <p:sp>
+        <p:nvSpPr>
+          <p:cNvPr id="10" name="Text 8"/>
+          <p:cNvSpPr txBox="1"/>
+          <p:nvPr/>
+        </p:nvSpPr>
+        <p:spPr>
+          <a:xfrm>
+            <a:off x="777240" y="3319272"/>
+            <a:ext cx="3566160" cy="960120"/>
+          </a:xfrm>
+          <a:prstGeom prst="rect">
+            <a:avLst/>
+          </a:prstGeom>
+          <a:noFill/>
+          <a:ln/>
+        </p:spPr>
+        <p:txBody>
+          <a:bodyPr wrap="square" lIns="0" tIns="0" rIns="0" bIns="0" rtlCol="0" anchor="ctr"/>
+          <a:lstStyle/>
+          <a:p>
+            <a:pPr indent="0" marL="0">
+              <a:buNone/>
+            </a:pPr>
+            <a:r>
+              <a:rPr lang="en-US" sz="1600" b="1" dirty="0">
+                <a:solidFill>
+                  <a:srgbClr val="1A1C1A"/>
+                </a:solidFill>
+                <a:latin typeface="Calibri" pitchFamily="34" charset="0"/>
+                <a:ea typeface="Calibri" pitchFamily="34" charset="-122"/>
+                <a:cs typeface="Calibri" pitchFamily="34" charset="-120"/>
+              </a:rPr>
+              <a:t>Magnesium bisglycinate, Vietnam pack</a:t>
+            </a:r>
+            <a:endParaRPr lang="en-US" sz="1600" dirty="0"/>
+          </a:p>
+        </p:txBody>
+      </p:sp>
+      <p:sp>
+        <p:nvSpPr>
+          <p:cNvPr id="11" name="Text 9"/>
+          <p:cNvSpPr txBox="1"/>
+          <p:nvPr/>
+        </p:nvSpPr>
+        <p:spPr>
+          <a:xfrm>
+            <a:off x="4389120" y="3319272"/>
+            <a:ext cx="2651760" cy="960120"/>
+          </a:xfrm>
+          <a:prstGeom prst="rect">
+            <a:avLst/>
+          </a:prstGeom>
+          <a:noFill/>
+          <a:ln/>
+        </p:spPr>
+        <p:txBody>
+          <a:bodyPr wrap="square" lIns="0" tIns="0" rIns="0" bIns="0" rtlCol="0" anchor="ctr"/>
+          <a:lstStyle/>
+          <a:p>
+            <a:pPr indent="0" marL="0">
+              <a:buNone/>
+            </a:pPr>
+            <a:r>
+              <a:rPr lang="en-US" sz="2600" b="1" dirty="0">
+                <a:solidFill>
+                  <a:srgbClr val="1F4D3A"/>
+                </a:solidFill>
+                <a:latin typeface="Cambria" pitchFamily="34" charset="0"/>
+                <a:ea typeface="Cambria" pitchFamily="34" charset="-122"/>
+                <a:cs typeface="Cambria" pitchFamily="34" charset="-120"/>
+              </a:rPr>
+              <a:t>VND 300–400k</a:t>
+            </a:r>
+            <a:endParaRPr lang="en-US" sz="2600" dirty="0"/>
+          </a:p>
+        </p:txBody>
+      </p:sp>
+      <p:sp>
+        <p:nvSpPr>
+          <p:cNvPr id="12" name="Text 10"/>
+          <p:cNvSpPr txBox="1"/>
+          <p:nvPr/>
+        </p:nvSpPr>
+        <p:spPr>
+          <a:xfrm>
+            <a:off x="7132320" y="3282696"/>
+            <a:ext cx="4297680" cy="640080"/>
+          </a:xfrm>
+          <a:prstGeom prst="rect">
+            <a:avLst/>
+          </a:prstGeom>
+          <a:noFill/>
+          <a:ln/>
+        </p:spPr>
+        <p:txBody>
+          <a:bodyPr wrap="square" lIns="0" tIns="0" rIns="0" bIns="0" rtlCol="0" anchor="ctr"/>
+          <a:lstStyle/>
+          <a:p>
+            <a:pPr indent="0" marL="0">
+              <a:buNone/>
+            </a:pPr>
+            <a:r>
+              <a:rPr lang="en-US" sz="1200" dirty="0">
+                <a:solidFill>
+                  <a:srgbClr val="5C635C"/>
+                </a:solidFill>
+                <a:latin typeface="Calibri" pitchFamily="34" charset="0"/>
+                <a:ea typeface="Calibri" pitchFamily="34" charset="-122"/>
+                <a:cs typeface="Calibri" pitchFamily="34" charset="-120"/>
+              </a:rPr>
+              <a:t>Doppelherz magnesium from VND 220k; Blackmores Bio Magnesium near VND 500k</a:t>
+            </a:r>
+            <a:endParaRPr lang="en-US" sz="1200" dirty="0"/>
+          </a:p>
+        </p:txBody>
+      </p:sp>
+      <p:sp>
+        <p:nvSpPr>
+          <p:cNvPr id="13" name="Text 11"/>
+          <p:cNvSpPr txBox="1"/>
+          <p:nvPr/>
+        </p:nvSpPr>
+        <p:spPr>
+          <a:xfrm>
+            <a:off x="7132320" y="3922776"/>
+            <a:ext cx="4297680" cy="384048"/>
+          </a:xfrm>
+          <a:prstGeom prst="rect">
+            <a:avLst/>
+          </a:prstGeom>
+          <a:noFill/>
+          <a:ln/>
+        </p:spPr>
+        <p:txBody>
+          <a:bodyPr wrap="square" lIns="0" tIns="0" rIns="0" bIns="0" rtlCol="0" anchor="ctr"/>
+          <a:lstStyle/>
+          <a:p>
+            <a:pPr indent="0" marL="0">
+              <a:buNone/>
+            </a:pPr>
+            <a:r>
+              <a:rPr lang="en-US" sz="1200" b="1" dirty="0">
+                <a:solidFill>
+                  <a:srgbClr val="C56A45"/>
+                </a:solidFill>
+                <a:latin typeface="Calibri" pitchFamily="34" charset="0"/>
+                <a:ea typeface="Calibri" pitchFamily="34" charset="-122"/>
+                <a:cs typeface="Calibri" pitchFamily="34" charset="-120"/>
+              </a:rPr>
+              <a:t>Premium, inside the band</a:t>
+            </a:r>
+            <a:endParaRPr lang="en-US" sz="1200" dirty="0"/>
+          </a:p>
+        </p:txBody>
+      </p:sp>
+      <p:sp>
+        <p:nvSpPr>
+          <p:cNvPr id="14" name="Shape 12"/>
+          <p:cNvSpPr/>
+          <p:nvPr/>
+        </p:nvSpPr>
+        <p:spPr>
+          <a:xfrm>
+            <a:off x="548640" y="4617720"/>
+            <a:ext cx="11064240" cy="1298448"/>
+          </a:xfrm>
+          <a:prstGeom prst="roundRect">
+            <a:avLst>
+              <a:gd name="adj" fmla="val 5634"/>
+            </a:avLst>
+          </a:prstGeom>
+          <a:solidFill>
+            <a:srgbClr val="EEF0EC"/>
+          </a:solidFill>
+          <a:ln/>
+          <a:effectLst>
+            <a:outerShdw sx="100000" sy="100000" kx="0" ky="0" algn="bl" rotWithShape="0" blurRad="63500" dist="25400" dir="5400000">
+              <a:srgbClr val="BBBBBB">
+                <a:alpha val="35000"/>
+              </a:srgbClr>
+            </a:outerShdw>
+          </a:effectLst>
+        </p:spPr>
+      </p:sp>
+      <p:sp>
+        <p:nvSpPr>
+          <p:cNvPr id="15" name="Text 13"/>
+          <p:cNvSpPr txBox="1"/>
+          <p:nvPr/>
+        </p:nvSpPr>
+        <p:spPr>
+          <a:xfrm>
+            <a:off x="777240" y="4782312"/>
+            <a:ext cx="3566160" cy="960120"/>
+          </a:xfrm>
+          <a:prstGeom prst="rect">
+            <a:avLst/>
+          </a:prstGeom>
+          <a:noFill/>
+          <a:ln/>
+        </p:spPr>
+        <p:txBody>
+          <a:bodyPr wrap="square" lIns="0" tIns="0" rIns="0" bIns="0" rtlCol="0" anchor="ctr"/>
+          <a:lstStyle/>
+          <a:p>
+            <a:pPr indent="0" marL="0">
+              <a:buNone/>
+            </a:pPr>
+            <a:r>
+              <a:rPr lang="en-US" sz="1600" b="1" dirty="0">
+                <a:solidFill>
+                  <a:srgbClr val="1A1C1A"/>
+                </a:solidFill>
+                <a:latin typeface="Calibri" pitchFamily="34" charset="0"/>
+                <a:ea typeface="Calibri" pitchFamily="34" charset="-122"/>
+                <a:cs typeface="Calibri" pitchFamily="34" charset="-120"/>
+              </a:rPr>
+              <a:t>Greens, smaller format</a:t>
+            </a:r>
+            <a:endParaRPr lang="en-US" sz="1600" dirty="0"/>
+          </a:p>
+        </p:txBody>
+      </p:sp>
+      <p:sp>
+        <p:nvSpPr>
+          <p:cNvPr id="16" name="Text 14"/>
+          <p:cNvSpPr txBox="1"/>
+          <p:nvPr/>
+        </p:nvSpPr>
+        <p:spPr>
+          <a:xfrm>
+            <a:off x="4389120" y="4782312"/>
+            <a:ext cx="2651760" cy="960120"/>
+          </a:xfrm>
+          <a:prstGeom prst="rect">
+            <a:avLst/>
+          </a:prstGeom>
+          <a:noFill/>
+          <a:ln/>
+        </p:spPr>
+        <p:txBody>
+          <a:bodyPr wrap="square" lIns="0" tIns="0" rIns="0" bIns="0" rtlCol="0" anchor="ctr"/>
+          <a:lstStyle/>
+          <a:p>
+            <a:pPr indent="0" marL="0">
+              <a:buNone/>
+            </a:pPr>
+            <a:r>
+              <a:rPr lang="en-US" sz="2600" b="1" dirty="0">
+                <a:solidFill>
+                  <a:srgbClr val="1F4D3A"/>
+                </a:solidFill>
+                <a:latin typeface="Cambria" pitchFamily="34" charset="0"/>
+                <a:ea typeface="Cambria" pitchFamily="34" charset="-122"/>
+                <a:cs typeface="Cambria" pitchFamily="34" charset="-120"/>
+              </a:rPr>
+              <a:t>VND 450–550k</a:t>
+            </a:r>
+            <a:endParaRPr lang="en-US" sz="2600" dirty="0"/>
+          </a:p>
+        </p:txBody>
+      </p:sp>
+      <p:sp>
+        <p:nvSpPr>
+          <p:cNvPr id="17" name="Text 15"/>
+          <p:cNvSpPr txBox="1"/>
+          <p:nvPr/>
+        </p:nvSpPr>
+        <p:spPr>
+          <a:xfrm>
+            <a:off x="7132320" y="4745736"/>
+            <a:ext cx="4297680" cy="640080"/>
+          </a:xfrm>
+          <a:prstGeom prst="rect">
+            <a:avLst/>
+          </a:prstGeom>
+          <a:noFill/>
+          <a:ln/>
+        </p:spPr>
+        <p:txBody>
+          <a:bodyPr wrap="square" lIns="0" tIns="0" rIns="0" bIns="0" rtlCol="0" anchor="ctr"/>
+          <a:lstStyle/>
+          <a:p>
+            <a:pPr indent="0" marL="0">
+              <a:buNone/>
+            </a:pPr>
+            <a:r>
+              <a:rPr lang="en-US" sz="1200" dirty="0">
+                <a:solidFill>
+                  <a:srgbClr val="5C635C"/>
+                </a:solidFill>
+                <a:latin typeface="Calibri" pitchFamily="34" charset="0"/>
+                <a:ea typeface="Calibri" pitchFamily="34" charset="-122"/>
+                <a:cs typeface="Calibri" pitchFamily="34" charset="-120"/>
+              </a:rPr>
+              <a:t>Orihiro aojiru greens VND 350–470k</a:t>
+            </a:r>
+            <a:endParaRPr lang="en-US" sz="1200" dirty="0"/>
+          </a:p>
+        </p:txBody>
+      </p:sp>
+      <p:sp>
+        <p:nvSpPr>
+          <p:cNvPr id="18" name="Text 16"/>
+          <p:cNvSpPr txBox="1"/>
+          <p:nvPr/>
+        </p:nvSpPr>
+        <p:spPr>
+          <a:xfrm>
+            <a:off x="7132320" y="5385816"/>
+            <a:ext cx="4297680" cy="384048"/>
+          </a:xfrm>
+          <a:prstGeom prst="rect">
+            <a:avLst/>
+          </a:prstGeom>
+          <a:noFill/>
+          <a:ln/>
+        </p:spPr>
+        <p:txBody>
+          <a:bodyPr wrap="square" lIns="0" tIns="0" rIns="0" bIns="0" rtlCol="0" anchor="ctr"/>
+          <a:lstStyle/>
+          <a:p>
+            <a:pPr indent="0" marL="0">
+              <a:buNone/>
+            </a:pPr>
+            <a:r>
+              <a:rPr lang="en-US" sz="1200" b="1" dirty="0">
+                <a:solidFill>
+                  <a:srgbClr val="C56A45"/>
+                </a:solidFill>
+                <a:latin typeface="Calibri" pitchFamily="34" charset="0"/>
+                <a:ea typeface="Calibri" pitchFamily="34" charset="-122"/>
+                <a:cs typeface="Calibri" pitchFamily="34" charset="-120"/>
+              </a:rPr>
+              <a:t>Premium, inside the band</a:t>
+            </a:r>
+            <a:endParaRPr lang="en-US" sz="1200" dirty="0"/>
+          </a:p>
+        </p:txBody>
+      </p:sp>
+      <p:sp>
+        <p:nvSpPr>
+          <p:cNvPr id="19" name="Text 17"/>
+          <p:cNvSpPr txBox="1"/>
+          <p:nvPr/>
+        </p:nvSpPr>
+        <p:spPr>
+          <a:xfrm>
+            <a:off x="548640" y="6080760"/>
+            <a:ext cx="11064240" cy="274320"/>
+          </a:xfrm>
+          <a:prstGeom prst="rect">
+            <a:avLst/>
+          </a:prstGeom>
+          <a:noFill/>
+          <a:ln/>
+        </p:spPr>
+        <p:txBody>
+          <a:bodyPr wrap="square" lIns="0" tIns="0" rIns="0" bIns="0" rtlCol="0" anchor="ctr"/>
+          <a:lstStyle/>
+          <a:p>
+            <a:pPr indent="0" marL="0">
+              <a:buNone/>
+            </a:pPr>
+            <a:r>
+              <a:rPr lang="en-US" sz="900" dirty="0">
+                <a:solidFill>
+                  <a:srgbClr val="5C635C"/>
+                </a:solidFill>
+                <a:latin typeface="Calibri" pitchFamily="34" charset="0"/>
+                <a:ea typeface="Calibri" pitchFamily="34" charset="-122"/>
+                <a:cs typeface="Calibri" pitchFamily="34" charset="-120"/>
+              </a:rPr>
+              <a:t>Competitor prices: Vietnamese retail and pharmacy listings, 2025 to 2026.</a:t>
+            </a:r>
+            <a:endParaRPr lang="en-US" sz="900" dirty="0"/>
+          </a:p>
+        </p:txBody>
+      </p:sp>
+      <p:sp>
+        <p:nvSpPr>
+          <p:cNvPr id="20" name="Text 18"/>
           <p:cNvSpPr txBox="1"/>
           <p:nvPr/>
         </p:nvSpPr>
@@ -6784,7 +6949,7 @@
       </p:sp>
       <p:sp>
         <p:nvSpPr>
-          <p:cNvPr id="10" name="Text 7"/>
+          <p:cNvPr id="21" name="Text 19"/>
           <p:cNvSpPr txBox="1"/>
           <p:nvPr/>
         </p:nvSpPr>
@@ -6886,7 +7051,7 @@
                 <a:ea typeface="Cambria" pitchFamily="34" charset="-122"/>
                 <a:cs typeface="Cambria" pitchFamily="34" charset="-120"/>
               </a:rPr>
-              <a:t>The plan: a 12-month runway to the first Tet</a:t>
+              <a:t>The plan: twelve months to the first Tet</a:t>
             </a:r>
             <a:endParaRPr lang="en-US" sz="3000" dirty="0"/>
           </a:p>
@@ -6982,8 +7147,8 @@
         </p:nvSpPr>
         <p:spPr>
           <a:xfrm>
-            <a:off x="640080" y="3291840"/>
-            <a:ext cx="2057400" cy="365760"/>
+            <a:off x="594360" y="3291840"/>
+            <a:ext cx="2148840" cy="365760"/>
           </a:xfrm>
           <a:prstGeom prst="rect">
             <a:avLst/>
@@ -6999,7 +7164,7 @@
               <a:buNone/>
             </a:pPr>
             <a:r>
-              <a:rPr lang="en-US" sz="1300" b="1" dirty="0">
+              <a:rPr lang="en-US" sz="1250" b="1" dirty="0">
                 <a:solidFill>
                   <a:srgbClr val="1F4D3A"/>
                 </a:solidFill>
@@ -7007,9 +7172,9 @@
                 <a:ea typeface="Calibri" pitchFamily="34" charset="-122"/>
                 <a:cs typeface="Calibri" pitchFamily="34" charset="-120"/>
               </a:rPr>
-              <a:t>Now – Sep</a:t>
-            </a:r>
-            <a:endParaRPr lang="en-US" sz="1300" dirty="0"/>
+              <a:t>Nov to Dec 2026</a:t>
+            </a:r>
+            <a:endParaRPr lang="en-US" sz="1250" dirty="0"/>
           </a:p>
         </p:txBody>
       </p:sp>
@@ -7021,8 +7186,8 @@
         </p:nvSpPr>
         <p:spPr>
           <a:xfrm>
-            <a:off x="640080" y="3657600"/>
-            <a:ext cx="2057400" cy="1005840"/>
+            <a:off x="640080" y="3703320"/>
+            <a:ext cx="2057400" cy="1097280"/>
           </a:xfrm>
           <a:prstGeom prst="rect">
             <a:avLst/>
@@ -7046,7 +7211,7 @@
                 <a:ea typeface="Calibri" pitchFamily="34" charset="-122"/>
                 <a:cs typeface="Calibri" pitchFamily="34" charset="-120"/>
               </a:rPr>
-              <a:t>Audit, IP filings, dossier assembly</a:t>
+              <a:t>Agree the partner plan, file trademarks, start dossiers</a:t>
             </a:r>
             <a:endParaRPr lang="en-US" sz="1150" dirty="0"/>
           </a:p>
@@ -7142,8 +7307,8 @@
         </p:nvSpPr>
         <p:spPr>
           <a:xfrm>
-            <a:off x="2880360" y="3291840"/>
-            <a:ext cx="2057400" cy="365760"/>
+            <a:off x="2834640" y="3291840"/>
+            <a:ext cx="2148840" cy="365760"/>
           </a:xfrm>
           <a:prstGeom prst="rect">
             <a:avLst/>
@@ -7159,7 +7324,7 @@
               <a:buNone/>
             </a:pPr>
             <a:r>
-              <a:rPr lang="en-US" sz="1300" b="1" dirty="0">
+              <a:rPr lang="en-US" sz="1250" b="1" dirty="0">
                 <a:solidFill>
                   <a:srgbClr val="1F4D3A"/>
                 </a:solidFill>
@@ -7167,9 +7332,9 @@
                 <a:ea typeface="Calibri" pitchFamily="34" charset="-122"/>
                 <a:cs typeface="Calibri" pitchFamily="34" charset="-120"/>
               </a:rPr>
-              <a:t>Sep – Jan</a:t>
-            </a:r>
-            <a:endParaRPr lang="en-US" sz="1300" dirty="0"/>
+              <a:t>Dec 2026 to Mar 2027</a:t>
+            </a:r>
+            <a:endParaRPr lang="en-US" sz="1250" dirty="0"/>
           </a:p>
         </p:txBody>
       </p:sp>
@@ -7181,8 +7346,8 @@
         </p:nvSpPr>
         <p:spPr>
           <a:xfrm>
-            <a:off x="2880360" y="3657600"/>
-            <a:ext cx="2057400" cy="1005840"/>
+            <a:off x="2880360" y="3703320"/>
+            <a:ext cx="2057400" cy="1097280"/>
           </a:xfrm>
           <a:prstGeom prst="rect">
             <a:avLst/>
@@ -7206,7 +7371,7 @@
                 <a:ea typeface="Calibri" pitchFamily="34" charset="-122"/>
                 <a:cs typeface="Calibri" pitchFamily="34" charset="-120"/>
               </a:rPr>
-              <a:t>File registrations; build Mall stores</a:t>
+              <a:t>File registrations; confirm the rules under the new food safety law</a:t>
             </a:r>
             <a:endParaRPr lang="en-US" sz="1150" dirty="0"/>
           </a:p>
@@ -7302,8 +7467,8 @@
         </p:nvSpPr>
         <p:spPr>
           <a:xfrm>
-            <a:off x="5120640" y="3291840"/>
-            <a:ext cx="2057400" cy="365760"/>
+            <a:off x="5074920" y="3291840"/>
+            <a:ext cx="2148840" cy="365760"/>
           </a:xfrm>
           <a:prstGeom prst="rect">
             <a:avLst/>
@@ -7319,7 +7484,7 @@
               <a:buNone/>
             </a:pPr>
             <a:r>
-              <a:rPr lang="en-US" sz="1300" b="1" dirty="0">
+              <a:rPr lang="en-US" sz="1250" b="1" dirty="0">
                 <a:solidFill>
                   <a:srgbClr val="1F4D3A"/>
                 </a:solidFill>
@@ -7327,9 +7492,9 @@
                 <a:ea typeface="Calibri" pitchFamily="34" charset="-122"/>
                 <a:cs typeface="Calibri" pitchFamily="34" charset="-120"/>
               </a:rPr>
-              <a:t>Feb – Apr</a:t>
-            </a:r>
-            <a:endParaRPr lang="en-US" sz="1300" dirty="0"/>
+              <a:t>Apr to Jun 2027</a:t>
+            </a:r>
+            <a:endParaRPr lang="en-US" sz="1250" dirty="0"/>
           </a:p>
         </p:txBody>
       </p:sp>
@@ -7341,8 +7506,8 @@
         </p:nvSpPr>
         <p:spPr>
           <a:xfrm>
-            <a:off x="5120640" y="3657600"/>
-            <a:ext cx="2057400" cy="1005840"/>
+            <a:off x="5120640" y="3703320"/>
+            <a:ext cx="2057400" cy="1097280"/>
           </a:xfrm>
           <a:prstGeom prst="rect">
             <a:avLst/>
@@ -7366,7 +7531,7 @@
                 <a:ea typeface="Calibri" pitchFamily="34" charset="-122"/>
                 <a:cs typeface="Calibri" pitchFamily="34" charset="-120"/>
               </a:rPr>
-              <a:t>Soft launch online after Tet; gather velocity</a:t>
+              <a:t>Official stores live; online launch; first sales data</a:t>
             </a:r>
             <a:endParaRPr lang="en-US" sz="1150" dirty="0"/>
           </a:p>
@@ -7462,8 +7627,8 @@
         </p:nvSpPr>
         <p:spPr>
           <a:xfrm>
-            <a:off x="7360920" y="3291840"/>
-            <a:ext cx="2057400" cy="365760"/>
+            <a:off x="7315200" y="3291840"/>
+            <a:ext cx="2148840" cy="365760"/>
           </a:xfrm>
           <a:prstGeom prst="rect">
             <a:avLst/>
@@ -7479,7 +7644,7 @@
               <a:buNone/>
             </a:pPr>
             <a:r>
-              <a:rPr lang="en-US" sz="1300" b="1" dirty="0">
+              <a:rPr lang="en-US" sz="1250" b="1" dirty="0">
                 <a:solidFill>
                   <a:srgbClr val="1F4D3A"/>
                 </a:solidFill>
@@ -7487,9 +7652,9 @@
                 <a:ea typeface="Calibri" pitchFamily="34" charset="-122"/>
                 <a:cs typeface="Calibri" pitchFamily="34" charset="-120"/>
               </a:rPr>
-              <a:t>Apr – Aug</a:t>
-            </a:r>
-            <a:endParaRPr lang="en-US" sz="1300" dirty="0"/>
+              <a:t>Jun to Aug 2027</a:t>
+            </a:r>
+            <a:endParaRPr lang="en-US" sz="1250" dirty="0"/>
           </a:p>
         </p:txBody>
       </p:sp>
@@ -7501,8 +7666,8 @@
         </p:nvSpPr>
         <p:spPr>
           <a:xfrm>
-            <a:off x="7360920" y="3657600"/>
-            <a:ext cx="2057400" cy="1005840"/>
+            <a:off x="7360920" y="3703320"/>
+            <a:ext cx="2057400" cy="1097280"/>
           </a:xfrm>
           <a:prstGeom prst="rect">
             <a:avLst/>
@@ -7526,7 +7691,7 @@
                 <a:ea typeface="Calibri" pitchFamily="34" charset="-122"/>
                 <a:cs typeface="Calibri" pitchFamily="34" charset="-120"/>
               </a:rPr>
-              <a:t>Long Chau &amp; Pharmacity listing push</a:t>
+              <a:t>Long Chau and Pharmacity listing push</a:t>
             </a:r>
             <a:endParaRPr lang="en-US" sz="1150" dirty="0"/>
           </a:p>
@@ -7599,8 +7764,8 @@
         </p:nvSpPr>
         <p:spPr>
           <a:xfrm>
-            <a:off x="9601200" y="3291840"/>
-            <a:ext cx="2057400" cy="365760"/>
+            <a:off x="9555480" y="3291840"/>
+            <a:ext cx="2148840" cy="365760"/>
           </a:xfrm>
           <a:prstGeom prst="rect">
             <a:avLst/>
@@ -7616,7 +7781,7 @@
               <a:buNone/>
             </a:pPr>
             <a:r>
-              <a:rPr lang="en-US" sz="1300" b="1" dirty="0">
+              <a:rPr lang="en-US" sz="1250" b="1" dirty="0">
                 <a:solidFill>
                   <a:srgbClr val="1F4D3A"/>
                 </a:solidFill>
@@ -7624,9 +7789,9 @@
                 <a:ea typeface="Calibri" pitchFamily="34" charset="-122"/>
                 <a:cs typeface="Calibri" pitchFamily="34" charset="-120"/>
               </a:rPr>
-              <a:t>Sep – Nov</a:t>
-            </a:r>
-            <a:endParaRPr lang="en-US" sz="1300" dirty="0"/>
+              <a:t>Sep to Nov 2027</a:t>
+            </a:r>
+            <a:endParaRPr lang="en-US" sz="1250" dirty="0"/>
           </a:p>
         </p:txBody>
       </p:sp>
@@ -7638,8 +7803,8 @@
         </p:nvSpPr>
         <p:spPr>
           <a:xfrm>
-            <a:off x="9601200" y="3657600"/>
-            <a:ext cx="2057400" cy="1005840"/>
+            <a:off x="9601200" y="3703320"/>
+            <a:ext cx="2057400" cy="1097280"/>
           </a:xfrm>
           <a:prstGeom prst="rect">
             <a:avLst/>
@@ -7663,7 +7828,7 @@
                 <a:ea typeface="Calibri" pitchFamily="34" charset="-122"/>
                 <a:cs typeface="Calibri" pitchFamily="34" charset="-120"/>
               </a:rPr>
-              <a:t>First Tet sell-in — gift SKU, chain displays</a:t>
+              <a:t>First Tet sell in: gift sets and chain displays</a:t>
             </a:r>
             <a:endParaRPr lang="en-US" sz="1150" dirty="0"/>
           </a:p>
@@ -7677,7 +7842,7 @@
         </p:nvSpPr>
         <p:spPr>
           <a:xfrm>
-            <a:off x="548640" y="5120640"/>
+            <a:off x="548640" y="5212080"/>
             <a:ext cx="11064240" cy="457200"/>
           </a:xfrm>
           <a:prstGeom prst="rect">
@@ -7702,7 +7867,7 @@
                 <a:ea typeface="Calibri" pitchFamily="34" charset="-122"/>
                 <a:cs typeface="Calibri" pitchFamily="34" charset="-120"/>
               </a:rPr>
-              <a:t>Tet 2027 falls on 6 February — the first full Tet play is Tet 2028, which sets this calendar.</a:t>
+              <a:t>Tet 2028 falls on 26 January, so the gift sell in runs September to November 2027.</a:t>
             </a:r>
             <a:endParaRPr lang="en-US" sz="1300" dirty="0"/>
           </a:p>

</xml_diff>

<commit_message>
Loop R9: deck plan slide uses target language; approvals set the pace
Co-Authored-By: Claude Opus 5.5 <noreply@anthropic.com>
Claude-Session: https://claude.ai/code/session_01CHL2VrJ5edbBW6zFNsXfxt
</commit_message>
<xml_diff>
--- a/vietnam-distributor-pitch.pptx
+++ b/vietnam-distributor-pitch.pptx
@@ -7059,7 +7059,46 @@
       </p:sp>
       <p:sp>
         <p:nvSpPr>
-          <p:cNvPr id="3" name="Shape 1"/>
+          <p:cNvPr id="3" name="Text 1"/>
+          <p:cNvSpPr txBox="1"/>
+          <p:nvPr/>
+        </p:nvSpPr>
+        <p:spPr>
+          <a:xfrm>
+            <a:off x="566928" y="1024128"/>
+            <a:ext cx="11064240" cy="365760"/>
+          </a:xfrm>
+          <a:prstGeom prst="rect">
+            <a:avLst/>
+          </a:prstGeom>
+          <a:noFill/>
+          <a:ln/>
+        </p:spPr>
+        <p:txBody>
+          <a:bodyPr wrap="square" lIns="0" tIns="0" rIns="0" bIns="0" rtlCol="0" anchor="ctr"/>
+          <a:lstStyle/>
+          <a:p>
+            <a:pPr indent="0" marL="0">
+              <a:buNone/>
+            </a:pPr>
+            <a:r>
+              <a:rPr lang="en-US" sz="1300" i="1" dirty="0">
+                <a:solidFill>
+                  <a:srgbClr val="C56A45"/>
+                </a:solidFill>
+                <a:latin typeface="Calibri" pitchFamily="34" charset="0"/>
+                <a:ea typeface="Calibri" pitchFamily="34" charset="-122"/>
+                <a:cs typeface="Calibri" pitchFamily="34" charset="-120"/>
+              </a:rPr>
+              <a:t>Target timeline; registration approvals set the pace</a:t>
+            </a:r>
+            <a:endParaRPr lang="en-US" sz="1300" dirty="0"/>
+          </a:p>
+        </p:txBody>
+      </p:sp>
+      <p:sp>
+        <p:nvSpPr>
+          <p:cNvPr id="4" name="Shape 2"/>
           <p:cNvSpPr/>
           <p:nvPr/>
         </p:nvSpPr>
@@ -7079,7 +7118,7 @@
       </p:sp>
       <p:sp>
         <p:nvSpPr>
-          <p:cNvPr id="4" name="Text 2"/>
+          <p:cNvPr id="5" name="Text 3"/>
           <p:cNvSpPr txBox="1"/>
           <p:nvPr/>
         </p:nvSpPr>
@@ -7118,7 +7157,7 @@
       </p:sp>
       <p:sp>
         <p:nvSpPr>
-          <p:cNvPr id="5" name="Shape 3"/>
+          <p:cNvPr id="6" name="Shape 4"/>
           <p:cNvSpPr/>
           <p:nvPr/>
         </p:nvSpPr>
@@ -7141,7 +7180,7 @@
       </p:sp>
       <p:sp>
         <p:nvSpPr>
-          <p:cNvPr id="6" name="Text 4"/>
+          <p:cNvPr id="7" name="Text 5"/>
           <p:cNvSpPr txBox="1"/>
           <p:nvPr/>
         </p:nvSpPr>
@@ -7180,7 +7219,7 @@
       </p:sp>
       <p:sp>
         <p:nvSpPr>
-          <p:cNvPr id="7" name="Text 5"/>
+          <p:cNvPr id="8" name="Text 6"/>
           <p:cNvSpPr txBox="1"/>
           <p:nvPr/>
         </p:nvSpPr>
@@ -7219,7 +7258,7 @@
       </p:sp>
       <p:sp>
         <p:nvSpPr>
-          <p:cNvPr id="8" name="Shape 6"/>
+          <p:cNvPr id="9" name="Shape 7"/>
           <p:cNvSpPr/>
           <p:nvPr/>
         </p:nvSpPr>
@@ -7239,7 +7278,7 @@
       </p:sp>
       <p:sp>
         <p:nvSpPr>
-          <p:cNvPr id="9" name="Text 7"/>
+          <p:cNvPr id="10" name="Text 8"/>
           <p:cNvSpPr txBox="1"/>
           <p:nvPr/>
         </p:nvSpPr>
@@ -7278,7 +7317,7 @@
       </p:sp>
       <p:sp>
         <p:nvSpPr>
-          <p:cNvPr id="10" name="Shape 8"/>
+          <p:cNvPr id="11" name="Shape 9"/>
           <p:cNvSpPr/>
           <p:nvPr/>
         </p:nvSpPr>
@@ -7301,7 +7340,7 @@
       </p:sp>
       <p:sp>
         <p:nvSpPr>
-          <p:cNvPr id="11" name="Text 9"/>
+          <p:cNvPr id="12" name="Text 10"/>
           <p:cNvSpPr txBox="1"/>
           <p:nvPr/>
         </p:nvSpPr>
@@ -7340,7 +7379,7 @@
       </p:sp>
       <p:sp>
         <p:nvSpPr>
-          <p:cNvPr id="12" name="Text 10"/>
+          <p:cNvPr id="13" name="Text 11"/>
           <p:cNvSpPr txBox="1"/>
           <p:nvPr/>
         </p:nvSpPr>
@@ -7379,7 +7418,7 @@
       </p:sp>
       <p:sp>
         <p:nvSpPr>
-          <p:cNvPr id="13" name="Shape 11"/>
+          <p:cNvPr id="14" name="Shape 12"/>
           <p:cNvSpPr/>
           <p:nvPr/>
         </p:nvSpPr>
@@ -7399,7 +7438,7 @@
       </p:sp>
       <p:sp>
         <p:nvSpPr>
-          <p:cNvPr id="14" name="Text 12"/>
+          <p:cNvPr id="15" name="Text 13"/>
           <p:cNvSpPr txBox="1"/>
           <p:nvPr/>
         </p:nvSpPr>
@@ -7438,7 +7477,7 @@
       </p:sp>
       <p:sp>
         <p:nvSpPr>
-          <p:cNvPr id="15" name="Shape 13"/>
+          <p:cNvPr id="16" name="Shape 14"/>
           <p:cNvSpPr/>
           <p:nvPr/>
         </p:nvSpPr>
@@ -7461,7 +7500,7 @@
       </p:sp>
       <p:sp>
         <p:nvSpPr>
-          <p:cNvPr id="16" name="Text 14"/>
+          <p:cNvPr id="17" name="Text 15"/>
           <p:cNvSpPr txBox="1"/>
           <p:nvPr/>
         </p:nvSpPr>
@@ -7500,7 +7539,7 @@
       </p:sp>
       <p:sp>
         <p:nvSpPr>
-          <p:cNvPr id="17" name="Text 15"/>
+          <p:cNvPr id="18" name="Text 16"/>
           <p:cNvSpPr txBox="1"/>
           <p:nvPr/>
         </p:nvSpPr>
@@ -7531,7 +7570,7 @@
                 <a:ea typeface="Calibri" pitchFamily="34" charset="-122"/>
                 <a:cs typeface="Calibri" pitchFamily="34" charset="-120"/>
               </a:rPr>
-              <a:t>Official stores live; online launch; first sales data</a:t>
+              <a:t>Official stores live as registrations clear; online launch; first sales data</a:t>
             </a:r>
             <a:endParaRPr lang="en-US" sz="1150" dirty="0"/>
           </a:p>
@@ -7539,7 +7578,7 @@
       </p:sp>
       <p:sp>
         <p:nvSpPr>
-          <p:cNvPr id="18" name="Shape 16"/>
+          <p:cNvPr id="19" name="Shape 17"/>
           <p:cNvSpPr/>
           <p:nvPr/>
         </p:nvSpPr>
@@ -7559,7 +7598,7 @@
       </p:sp>
       <p:sp>
         <p:nvSpPr>
-          <p:cNvPr id="19" name="Text 17"/>
+          <p:cNvPr id="20" name="Text 18"/>
           <p:cNvSpPr txBox="1"/>
           <p:nvPr/>
         </p:nvSpPr>
@@ -7598,7 +7637,7 @@
       </p:sp>
       <p:sp>
         <p:nvSpPr>
-          <p:cNvPr id="20" name="Shape 18"/>
+          <p:cNvPr id="21" name="Shape 19"/>
           <p:cNvSpPr/>
           <p:nvPr/>
         </p:nvSpPr>
@@ -7621,7 +7660,7 @@
       </p:sp>
       <p:sp>
         <p:nvSpPr>
-          <p:cNvPr id="21" name="Text 19"/>
+          <p:cNvPr id="22" name="Text 20"/>
           <p:cNvSpPr txBox="1"/>
           <p:nvPr/>
         </p:nvSpPr>
@@ -7660,7 +7699,7 @@
       </p:sp>
       <p:sp>
         <p:nvSpPr>
-          <p:cNvPr id="22" name="Text 20"/>
+          <p:cNvPr id="23" name="Text 21"/>
           <p:cNvSpPr txBox="1"/>
           <p:nvPr/>
         </p:nvSpPr>
@@ -7699,7 +7738,7 @@
       </p:sp>
       <p:sp>
         <p:nvSpPr>
-          <p:cNvPr id="23" name="Shape 21"/>
+          <p:cNvPr id="24" name="Shape 22"/>
           <p:cNvSpPr/>
           <p:nvPr/>
         </p:nvSpPr>
@@ -7719,7 +7758,7 @@
       </p:sp>
       <p:sp>
         <p:nvSpPr>
-          <p:cNvPr id="24" name="Text 22"/>
+          <p:cNvPr id="25" name="Text 23"/>
           <p:cNvSpPr txBox="1"/>
           <p:nvPr/>
         </p:nvSpPr>
@@ -7758,7 +7797,7 @@
       </p:sp>
       <p:sp>
         <p:nvSpPr>
-          <p:cNvPr id="25" name="Text 23"/>
+          <p:cNvPr id="26" name="Text 24"/>
           <p:cNvSpPr txBox="1"/>
           <p:nvPr/>
         </p:nvSpPr>
@@ -7797,7 +7836,7 @@
       </p:sp>
       <p:sp>
         <p:nvSpPr>
-          <p:cNvPr id="26" name="Text 24"/>
+          <p:cNvPr id="27" name="Text 25"/>
           <p:cNvSpPr txBox="1"/>
           <p:nvPr/>
         </p:nvSpPr>
@@ -7836,7 +7875,7 @@
       </p:sp>
       <p:sp>
         <p:nvSpPr>
-          <p:cNvPr id="27" name="Text 25"/>
+          <p:cNvPr id="28" name="Text 26"/>
           <p:cNvSpPr txBox="1"/>
           <p:nvPr/>
         </p:nvSpPr>
@@ -7875,7 +7914,7 @@
       </p:sp>
       <p:sp>
         <p:nvSpPr>
-          <p:cNvPr id="28" name="Text 26"/>
+          <p:cNvPr id="29" name="Text 27"/>
           <p:cNvSpPr txBox="1"/>
           <p:nvPr/>
         </p:nvSpPr>
@@ -7914,7 +7953,7 @@
       </p:sp>
       <p:sp>
         <p:nvSpPr>
-          <p:cNvPr id="29" name="Text 27"/>
+          <p:cNvPr id="30" name="Text 28"/>
           <p:cNvSpPr txBox="1"/>
           <p:nvPr/>
         </p:nvSpPr>

</xml_diff>